<commit_message>
docs: add dedicated Layer 2 preprocessing pipeline slide to presentation
</commit_message>
<xml_diff>
--- a/Review_1_Presentation.pptx
+++ b/Review_1_Presentation.pptx
@@ -17,6 +17,7 @@
     <p:sldId id="265" r:id="rId16"/>
     <p:sldId id="266" r:id="rId17"/>
     <p:sldId id="267" r:id="rId18"/>
+    <p:sldId id="268" r:id="rId19"/>
   </p:sldIdLst>
   <p:sldSz cx="12191695" cy="6858000" type="screen4x3"/>
   <p:notesSz cx="6858000" cy="9144000"/>
@@ -3311,7 +3312,7 @@
         <p:spPr>
           <a:xfrm>
             <a:off x="1371600" y="1920240"/>
-            <a:ext cx="9418320" cy="1097280"/>
+            <a:ext cx="9418320" cy="1005840"/>
           </a:xfrm>
           <a:prstGeom prst="rect">
             <a:avLst/>
@@ -3568,7 +3569,7 @@
               </a:defRPr>
             </a:pPr>
             <a:r>
-              <a:t>SUPERVISION &amp; INSTITUTION</a:t>
+              <a:t>SUPERVISION &amp; REPOSITORY</a:t>
             </a:r>
           </a:p>
           <a:p>
@@ -3679,7 +3680,7 @@
         <p:spPr>
           <a:xfrm>
             <a:off x="731520" y="365760"/>
-            <a:ext cx="7315200" cy="320040"/>
+            <a:ext cx="7772400" cy="292608"/>
           </a:xfrm>
           <a:prstGeom prst="rect">
             <a:avLst/>
@@ -3701,7 +3702,7 @@
               </a:defRPr>
             </a:pPr>
             <a:r>
-              <a:t>9. PROPOSED METHODOLOGY</a:t>
+              <a:t>9. REVIEW 1 DELIVERABLES</a:t>
             </a:r>
           </a:p>
         </p:txBody>
@@ -3714,7 +3715,7 @@
         </p:nvSpPr>
         <p:spPr>
           <a:xfrm>
-            <a:off x="731520" y="685800"/>
+            <a:off x="731520" y="658368"/>
             <a:ext cx="9601200" cy="594360"/>
           </a:xfrm>
           <a:prstGeom prst="rect">
@@ -3737,7 +3738,7 @@
               </a:defRPr>
             </a:pPr>
             <a:r>
-              <a:t>Proposed Methodology &amp; System Architecture</a:t>
+              <a:t>Work Done So Far (Review 1 Deliverables)</a:t>
             </a:r>
           </a:p>
         </p:txBody>
@@ -3750,7 +3751,7 @@
         </p:nvSpPr>
         <p:spPr>
           <a:xfrm>
-            <a:off x="10789920" y="457200"/>
+            <a:off x="10789920" y="411480"/>
             <a:ext cx="685800" cy="320040"/>
           </a:xfrm>
           <a:prstGeom prst="roundRect">
@@ -3792,383 +3793,603 @@
               </a:defRPr>
             </a:pPr>
             <a:r>
-              <a:t>10/12</a:t>
-            </a:r>
-          </a:p>
-        </p:txBody>
-      </p:sp>
-      <p:sp>
-        <p:nvSpPr>
-          <p:cNvPr id="6" name="Rounded Rectangle 5"/>
-          <p:cNvSpPr/>
+              <a:t>10/13</a:t>
+            </a:r>
+          </a:p>
+        </p:txBody>
+      </p:sp>
+      <p:graphicFrame>
+        <p:nvGraphicFramePr>
+          <p:cNvPr id="6" name="Table 5"/>
+          <p:cNvGraphicFramePr>
+            <a:graphicFrameLocks noGrp="1"/>
+          </p:cNvGraphicFramePr>
           <p:nvPr/>
-        </p:nvSpPr>
-        <p:spPr>
-          <a:xfrm>
-            <a:off x="731520" y="1508760"/>
-            <a:ext cx="10728655" cy="694944"/>
-          </a:xfrm>
-          <a:prstGeom prst="roundRect">
-            <a:avLst/>
-          </a:prstGeom>
-          <a:solidFill>
-            <a:srgbClr val="FFFFFF"/>
-          </a:solidFill>
-          <a:ln w="15240">
-            <a:solidFill>
-              <a:srgbClr val="0284C7"/>
-            </a:solidFill>
-          </a:ln>
-        </p:spPr>
-        <p:style>
-          <a:lnRef idx="1">
-            <a:schemeClr val="accent1"/>
-          </a:lnRef>
-          <a:fillRef idx="3">
-            <a:schemeClr val="accent1"/>
-          </a:fillRef>
-          <a:effectRef idx="2">
-            <a:schemeClr val="accent1"/>
-          </a:effectRef>
-          <a:fontRef idx="minor">
-            <a:schemeClr val="lt1"/>
-          </a:fontRef>
-        </p:style>
-        <p:txBody>
-          <a:bodyPr rtlCol="0" anchor="ctr" wrap="square"/>
-          <a:lstStyle/>
-          <a:p>
-            <a:pPr algn="ctr">
-              <a:defRPr b="1" sz="1150">
-                <a:solidFill>
-                  <a:srgbClr val="0284C7"/>
-                </a:solidFill>
-              </a:defRPr>
-            </a:pPr>
-            <a:r>
-              <a:t>1. Data Ingestion Layer:  </a:t>
-            </a:r>
-            <a:r>
-              <a:rPr b="0" sz="1000">
-                <a:solidFill>
-                  <a:srgbClr val="334155"/>
-                </a:solidFill>
-              </a:rPr>
-              <a:t>4,083 FracAtlas radiographs + COCO bounding box &amp; mask annotations (download_dataset.py)</a:t>
-            </a:r>
-          </a:p>
-        </p:txBody>
-      </p:sp>
-      <p:sp>
-        <p:nvSpPr>
-          <p:cNvPr id="7" name="Rounded Rectangle 6"/>
-          <p:cNvSpPr/>
-          <p:nvPr/>
-        </p:nvSpPr>
-        <p:spPr>
-          <a:xfrm>
-            <a:off x="731520" y="2313432"/>
-            <a:ext cx="10728655" cy="694944"/>
-          </a:xfrm>
-          <a:prstGeom prst="roundRect">
-            <a:avLst/>
-          </a:prstGeom>
-          <a:solidFill>
-            <a:srgbClr val="FFFFFF"/>
-          </a:solidFill>
-          <a:ln w="15240">
-            <a:solidFill>
-              <a:srgbClr val="0284C7"/>
-            </a:solidFill>
-          </a:ln>
-        </p:spPr>
-        <p:style>
-          <a:lnRef idx="1">
-            <a:schemeClr val="accent1"/>
-          </a:lnRef>
-          <a:fillRef idx="3">
-            <a:schemeClr val="accent1"/>
-          </a:fillRef>
-          <a:effectRef idx="2">
-            <a:schemeClr val="accent1"/>
-          </a:effectRef>
-          <a:fontRef idx="minor">
-            <a:schemeClr val="lt1"/>
-          </a:fontRef>
-        </p:style>
-        <p:txBody>
-          <a:bodyPr rtlCol="0" anchor="ctr" wrap="square"/>
-          <a:lstStyle/>
-          <a:p>
-            <a:pPr algn="ctr">
-              <a:defRPr b="1" sz="1150">
-                <a:solidFill>
-                  <a:srgbClr val="0284C7"/>
-                </a:solidFill>
-              </a:defRPr>
-            </a:pPr>
-            <a:r>
-              <a:t>2. Preprocessing &amp; Instruction Tuning:  </a:t>
-            </a:r>
-            <a:r>
-              <a:rPr b="0" sz="1000">
-                <a:solidFill>
-                  <a:srgbClr val="334155"/>
-                </a:solidFill>
-              </a:rPr>
-              <a:t>1:1 balanced sampling producing 1,438 LLaVA-format conversation pairs with clinical queries (src/dataset_to_vlm.py)</a:t>
-            </a:r>
-          </a:p>
-        </p:txBody>
-      </p:sp>
-      <p:sp>
-        <p:nvSpPr>
-          <p:cNvPr id="8" name="Rounded Rectangle 7"/>
-          <p:cNvSpPr/>
-          <p:nvPr/>
-        </p:nvSpPr>
-        <p:spPr>
-          <a:xfrm>
-            <a:off x="731520" y="3118104"/>
-            <a:ext cx="10728655" cy="694944"/>
-          </a:xfrm>
-          <a:prstGeom prst="roundRect">
-            <a:avLst/>
-          </a:prstGeom>
-          <a:solidFill>
-            <a:srgbClr val="FFFFFF"/>
-          </a:solidFill>
-          <a:ln w="15240">
-            <a:solidFill>
-              <a:srgbClr val="0D9488"/>
-            </a:solidFill>
-          </a:ln>
-        </p:spPr>
-        <p:style>
-          <a:lnRef idx="1">
-            <a:schemeClr val="accent1"/>
-          </a:lnRef>
-          <a:fillRef idx="3">
-            <a:schemeClr val="accent1"/>
-          </a:fillRef>
-          <a:effectRef idx="2">
-            <a:schemeClr val="accent1"/>
-          </a:effectRef>
-          <a:fontRef idx="minor">
-            <a:schemeClr val="lt1"/>
-          </a:fontRef>
-        </p:style>
-        <p:txBody>
-          <a:bodyPr rtlCol="0" anchor="ctr" wrap="square"/>
-          <a:lstStyle/>
-          <a:p>
-            <a:pPr algn="ctr">
-              <a:defRPr b="1" sz="1150">
-                <a:solidFill>
-                  <a:srgbClr val="0D9488"/>
-                </a:solidFill>
-              </a:defRPr>
-            </a:pPr>
-            <a:r>
-              <a:t>3. Foundation Model &amp; Baseline:  </a:t>
-            </a:r>
-            <a:r>
-              <a:rPr b="0" sz="1000">
-                <a:solidFill>
-                  <a:srgbClr val="334155"/>
-                </a:solidFill>
-              </a:rPr>
-              <a:t>Qwen2-VL-2B-Instruct multimodal backbone with dynamic-resolution Vision Transformer (ViT) &amp; M-RoPE embeddings</a:t>
-            </a:r>
-          </a:p>
-        </p:txBody>
-      </p:sp>
-      <p:sp>
-        <p:nvSpPr>
-          <p:cNvPr id="9" name="Rounded Rectangle 8"/>
-          <p:cNvSpPr/>
-          <p:nvPr/>
-        </p:nvSpPr>
-        <p:spPr>
-          <a:xfrm>
-            <a:off x="731520" y="3922776"/>
-            <a:ext cx="10728655" cy="694944"/>
-          </a:xfrm>
-          <a:prstGeom prst="roundRect">
-            <a:avLst/>
-          </a:prstGeom>
-          <a:solidFill>
-            <a:srgbClr val="FFFFFF"/>
-          </a:solidFill>
-          <a:ln w="15240">
-            <a:solidFill>
-              <a:srgbClr val="0D9488"/>
-            </a:solidFill>
-          </a:ln>
-        </p:spPr>
-        <p:style>
-          <a:lnRef idx="1">
-            <a:schemeClr val="accent1"/>
-          </a:lnRef>
-          <a:fillRef idx="3">
-            <a:schemeClr val="accent1"/>
-          </a:fillRef>
-          <a:effectRef idx="2">
-            <a:schemeClr val="accent1"/>
-          </a:effectRef>
-          <a:fontRef idx="minor">
-            <a:schemeClr val="lt1"/>
-          </a:fontRef>
-        </p:style>
-        <p:txBody>
-          <a:bodyPr rtlCol="0" anchor="ctr" wrap="square"/>
-          <a:lstStyle/>
-          <a:p>
-            <a:pPr algn="ctr">
-              <a:defRPr b="1" sz="1150">
-                <a:solidFill>
-                  <a:srgbClr val="0D9488"/>
-                </a:solidFill>
-              </a:defRPr>
-            </a:pPr>
-            <a:r>
-              <a:t>4. Parameter-Efficient Fine-Tuning (PEFT):  </a:t>
-            </a:r>
-            <a:r>
-              <a:rPr b="0" sz="1000">
-                <a:solidFill>
-                  <a:srgbClr val="334155"/>
-                </a:solidFill>
-              </a:rPr>
-              <a:t>QLoRA 4-bit NormalFloat (NF4) via BitsAndBytes on attention projections (q_proj, k_proj, v_proj, o_proj)</a:t>
-            </a:r>
-          </a:p>
-        </p:txBody>
-      </p:sp>
-      <p:sp>
-        <p:nvSpPr>
-          <p:cNvPr id="10" name="Rounded Rectangle 9"/>
-          <p:cNvSpPr/>
-          <p:nvPr/>
-        </p:nvSpPr>
-        <p:spPr>
-          <a:xfrm>
-            <a:off x="731520" y="4727448"/>
-            <a:ext cx="10728655" cy="694944"/>
-          </a:xfrm>
-          <a:prstGeom prst="roundRect">
-            <a:avLst/>
-          </a:prstGeom>
-          <a:solidFill>
-            <a:srgbClr val="FFFFFF"/>
-          </a:solidFill>
-          <a:ln w="15240">
-            <a:solidFill>
-              <a:srgbClr val="0F172A"/>
-            </a:solidFill>
-          </a:ln>
-        </p:spPr>
-        <p:style>
-          <a:lnRef idx="1">
-            <a:schemeClr val="accent1"/>
-          </a:lnRef>
-          <a:fillRef idx="3">
-            <a:schemeClr val="accent1"/>
-          </a:fillRef>
-          <a:effectRef idx="2">
-            <a:schemeClr val="accent1"/>
-          </a:effectRef>
-          <a:fontRef idx="minor">
-            <a:schemeClr val="lt1"/>
-          </a:fontRef>
-        </p:style>
-        <p:txBody>
-          <a:bodyPr rtlCol="0" anchor="ctr" wrap="square"/>
-          <a:lstStyle/>
-          <a:p>
-            <a:pPr algn="ctr">
-              <a:defRPr b="1" sz="1150">
-                <a:solidFill>
-                  <a:srgbClr val="0F172A"/>
-                </a:solidFill>
-              </a:defRPr>
-            </a:pPr>
-            <a:r>
-              <a:t>5. Diagnostic Inference Core:  </a:t>
-            </a:r>
-            <a:r>
-              <a:rPr b="0" sz="1000">
-                <a:solidFill>
-                  <a:srgbClr val="334155"/>
-                </a:solidFill>
-              </a:rPr>
-              <a:t>Central inference engine executing fracture detection, coordinate localization, and routing to clinical outputs</a:t>
-            </a:r>
-          </a:p>
-        </p:txBody>
-      </p:sp>
-      <p:sp>
-        <p:nvSpPr>
-          <p:cNvPr id="11" name="Rounded Rectangle 10"/>
-          <p:cNvSpPr/>
-          <p:nvPr/>
-        </p:nvSpPr>
-        <p:spPr>
-          <a:xfrm>
-            <a:off x="731520" y="5532120"/>
-            <a:ext cx="10728655" cy="694944"/>
-          </a:xfrm>
-          <a:prstGeom prst="roundRect">
-            <a:avLst/>
-          </a:prstGeom>
-          <a:solidFill>
-            <a:srgbClr val="FFFFFF"/>
-          </a:solidFill>
-          <a:ln w="15240">
-            <a:solidFill>
-              <a:srgbClr val="0F172A"/>
-            </a:solidFill>
-          </a:ln>
-        </p:spPr>
-        <p:style>
-          <a:lnRef idx="1">
-            <a:schemeClr val="accent1"/>
-          </a:lnRef>
-          <a:fillRef idx="3">
-            <a:schemeClr val="accent1"/>
-          </a:fillRef>
-          <a:effectRef idx="2">
-            <a:schemeClr val="accent1"/>
-          </a:effectRef>
-          <a:fontRef idx="minor">
-            <a:schemeClr val="lt1"/>
-          </a:fontRef>
-        </p:style>
-        <p:txBody>
-          <a:bodyPr rtlCol="0" anchor="ctr" wrap="square"/>
-          <a:lstStyle/>
-          <a:p>
-            <a:pPr algn="ctr">
-              <a:defRPr b="1" sz="1150">
-                <a:solidFill>
-                  <a:srgbClr val="0F172A"/>
-                </a:solidFill>
-              </a:defRPr>
-            </a:pPr>
-            <a:r>
-              <a:t>6. Clinical Interfaces &amp; Reporting:  </a:t>
-            </a:r>
-            <a:r>
-              <a:rPr b="0" sz="1000">
-                <a:solidFill>
-                  <a:srgbClr val="334155"/>
-                </a:solidFill>
-              </a:rPr>
-              <a:t>Interactive Gradio Med-VQA Chat UI (src/app.py) + Automated ACR Clinical Radiology PDF Reports</a:t>
-            </a:r>
-          </a:p>
-        </p:txBody>
-      </p:sp>
+        </p:nvGraphicFramePr>
+        <p:xfrm>
+          <a:off x="731520" y="1508760"/>
+          <a:ext cx="10728655" cy="4663440"/>
+        </p:xfrm>
+        <a:graphic>
+          <a:graphicData uri="http://schemas.openxmlformats.org/drawingml/2006/table">
+            <a:tbl>
+              <a:tblPr firstRow="1" bandRow="1">
+                <a:tableStyleId>{5C22544A-7EE6-4342-B048-85BDC9FD1C3A}</a:tableStyleId>
+              </a:tblPr>
+              <a:tblGrid>
+                <a:gridCol w="2011680"/>
+                <a:gridCol w="2103120"/>
+                <a:gridCol w="1645920"/>
+                <a:gridCol w="4967935"/>
+              </a:tblGrid>
+              <a:tr h="777240">
+                <a:tc>
+                  <a:txBody>
+                    <a:bodyPr/>
+                    <a:lstStyle/>
+                    <a:p>
+                      <a:pPr>
+                        <a:defRPr b="1" sz="1050">
+                          <a:solidFill>
+                            <a:srgbClr val="FFFFFF"/>
+                          </a:solidFill>
+                        </a:defRPr>
+                      </a:pPr>
+                      <a:r>
+                        <a:t>Milestone Module</a:t>
+                      </a:r>
+                    </a:p>
+                  </a:txBody>
+                  <a:tcPr>
+                    <a:solidFill>
+                      <a:srgbClr val="0F172A"/>
+                    </a:solidFill>
+                  </a:tcPr>
+                </a:tc>
+                <a:tc>
+                  <a:txBody>
+                    <a:bodyPr/>
+                    <a:lstStyle/>
+                    <a:p>
+                      <a:pPr>
+                        <a:defRPr b="1" sz="1050">
+                          <a:solidFill>
+                            <a:srgbClr val="FFFFFF"/>
+                          </a:solidFill>
+                        </a:defRPr>
+                      </a:pPr>
+                      <a:r>
+                        <a:t>Associated Script / Path</a:t>
+                      </a:r>
+                    </a:p>
+                  </a:txBody>
+                  <a:tcPr>
+                    <a:solidFill>
+                      <a:srgbClr val="0F172A"/>
+                    </a:solidFill>
+                  </a:tcPr>
+                </a:tc>
+                <a:tc>
+                  <a:txBody>
+                    <a:bodyPr/>
+                    <a:lstStyle/>
+                    <a:p>
+                      <a:pPr>
+                        <a:defRPr b="1" sz="1050">
+                          <a:solidFill>
+                            <a:srgbClr val="FFFFFF"/>
+                          </a:solidFill>
+                        </a:defRPr>
+                      </a:pPr>
+                      <a:r>
+                        <a:t>Review 1 Status</a:t>
+                      </a:r>
+                    </a:p>
+                  </a:txBody>
+                  <a:tcPr>
+                    <a:solidFill>
+                      <a:srgbClr val="0F172A"/>
+                    </a:solidFill>
+                  </a:tcPr>
+                </a:tc>
+                <a:tc>
+                  <a:txBody>
+                    <a:bodyPr/>
+                    <a:lstStyle/>
+                    <a:p>
+                      <a:pPr>
+                        <a:defRPr b="1" sz="1050">
+                          <a:solidFill>
+                            <a:srgbClr val="FFFFFF"/>
+                          </a:solidFill>
+                        </a:defRPr>
+                      </a:pPr>
+                      <a:r>
+                        <a:t>Delivered Capability</a:t>
+                      </a:r>
+                    </a:p>
+                  </a:txBody>
+                  <a:tcPr>
+                    <a:solidFill>
+                      <a:srgbClr val="0F172A"/>
+                    </a:solidFill>
+                  </a:tcPr>
+                </a:tc>
+              </a:tr>
+              <a:tr h="777240">
+                <a:tc>
+                  <a:txBody>
+                    <a:bodyPr/>
+                    <a:lstStyle/>
+                    <a:p>
+                      <a:pPr>
+                        <a:defRPr sz="1000" b="1">
+                          <a:solidFill>
+                            <a:srgbClr val="334155"/>
+                          </a:solidFill>
+                        </a:defRPr>
+                      </a:pPr>
+                      <a:r>
+                        <a:t>Layer 1: Dataset Ingestion</a:t>
+                      </a:r>
+                    </a:p>
+                  </a:txBody>
+                  <a:tcPr>
+                    <a:solidFill>
+                      <a:srgbClr val="FFFFFF"/>
+                    </a:solidFill>
+                  </a:tcPr>
+                </a:tc>
+                <a:tc>
+                  <a:txBody>
+                    <a:bodyPr/>
+                    <a:lstStyle/>
+                    <a:p>
+                      <a:pPr>
+                        <a:defRPr sz="1000" b="0">
+                          <a:solidFill>
+                            <a:srgbClr val="334155"/>
+                          </a:solidFill>
+                        </a:defRPr>
+                      </a:pPr>
+                      <a:r>
+                        <a:t>download_dataset.py</a:t>
+                      </a:r>
+                    </a:p>
+                  </a:txBody>
+                  <a:tcPr>
+                    <a:solidFill>
+                      <a:srgbClr val="FFFFFF"/>
+                    </a:solidFill>
+                  </a:tcPr>
+                </a:tc>
+                <a:tc>
+                  <a:txBody>
+                    <a:bodyPr/>
+                    <a:lstStyle/>
+                    <a:p>
+                      <a:pPr>
+                        <a:defRPr sz="1000" b="1">
+                          <a:solidFill>
+                            <a:srgbClr val="0D9488"/>
+                          </a:solidFill>
+                        </a:defRPr>
+                      </a:pPr>
+                      <a:r>
+                        <a:t>✅ Completed</a:t>
+                      </a:r>
+                    </a:p>
+                  </a:txBody>
+                  <a:tcPr>
+                    <a:solidFill>
+                      <a:srgbClr val="FFFFFF"/>
+                    </a:solidFill>
+                  </a:tcPr>
+                </a:tc>
+                <a:tc>
+                  <a:txBody>
+                    <a:bodyPr/>
+                    <a:lstStyle/>
+                    <a:p>
+                      <a:pPr>
+                        <a:defRPr sz="1000" b="0">
+                          <a:solidFill>
+                            <a:srgbClr val="334155"/>
+                          </a:solidFill>
+                        </a:defRPr>
+                      </a:pPr>
+                      <a:r>
+                        <a:t>Automated script fetching, verifying MD5 checksum, and extracting 4,083 scans.</a:t>
+                      </a:r>
+                    </a:p>
+                  </a:txBody>
+                  <a:tcPr>
+                    <a:solidFill>
+                      <a:srgbClr val="FFFFFF"/>
+                    </a:solidFill>
+                  </a:tcPr>
+                </a:tc>
+              </a:tr>
+              <a:tr h="777240">
+                <a:tc>
+                  <a:txBody>
+                    <a:bodyPr/>
+                    <a:lstStyle/>
+                    <a:p>
+                      <a:pPr>
+                        <a:defRPr sz="1000" b="1">
+                          <a:solidFill>
+                            <a:srgbClr val="334155"/>
+                          </a:solidFill>
+                        </a:defRPr>
+                      </a:pPr>
+                      <a:r>
+                        <a:t>Layer 2: Preprocessing Pipeline</a:t>
+                      </a:r>
+                    </a:p>
+                  </a:txBody>
+                  <a:tcPr>
+                    <a:solidFill>
+                      <a:srgbClr val="FFFFFF"/>
+                    </a:solidFill>
+                  </a:tcPr>
+                </a:tc>
+                <a:tc>
+                  <a:txBody>
+                    <a:bodyPr/>
+                    <a:lstStyle/>
+                    <a:p>
+                      <a:pPr>
+                        <a:defRPr sz="1000" b="0">
+                          <a:solidFill>
+                            <a:srgbClr val="334155"/>
+                          </a:solidFill>
+                        </a:defRPr>
+                      </a:pPr>
+                      <a:r>
+                        <a:t>src/dataset_to_vlm.py</a:t>
+                      </a:r>
+                    </a:p>
+                  </a:txBody>
+                  <a:tcPr>
+                    <a:solidFill>
+                      <a:srgbClr val="FFFFFF"/>
+                    </a:solidFill>
+                  </a:tcPr>
+                </a:tc>
+                <a:tc>
+                  <a:txBody>
+                    <a:bodyPr/>
+                    <a:lstStyle/>
+                    <a:p>
+                      <a:pPr>
+                        <a:defRPr sz="1000" b="1">
+                          <a:solidFill>
+                            <a:srgbClr val="0D9488"/>
+                          </a:solidFill>
+                        </a:defRPr>
+                      </a:pPr>
+                      <a:r>
+                        <a:t>✅ Completed</a:t>
+                      </a:r>
+                    </a:p>
+                  </a:txBody>
+                  <a:tcPr>
+                    <a:solidFill>
+                      <a:srgbClr val="FFFFFF"/>
+                    </a:solidFill>
+                  </a:tcPr>
+                </a:tc>
+                <a:tc>
+                  <a:txBody>
+                    <a:bodyPr/>
+                    <a:lstStyle/>
+                    <a:p>
+                      <a:pPr>
+                        <a:defRPr sz="1000" b="0">
+                          <a:solidFill>
+                            <a:srgbClr val="334155"/>
+                          </a:solidFill>
+                        </a:defRPr>
+                      </a:pPr>
+                      <a:r>
+                        <a:t>Enforced 1:1 balanced sampling; created 1,438 LLaVA dialogue pairs (train: 1,148, val: 164, test: 126).</a:t>
+                      </a:r>
+                    </a:p>
+                  </a:txBody>
+                  <a:tcPr>
+                    <a:solidFill>
+                      <a:srgbClr val="FFFFFF"/>
+                    </a:solidFill>
+                  </a:tcPr>
+                </a:tc>
+              </a:tr>
+              <a:tr h="777240">
+                <a:tc>
+                  <a:txBody>
+                    <a:bodyPr/>
+                    <a:lstStyle/>
+                    <a:p>
+                      <a:pPr>
+                        <a:defRPr sz="1000" b="1">
+                          <a:solidFill>
+                            <a:srgbClr val="334155"/>
+                          </a:solidFill>
+                        </a:defRPr>
+                      </a:pPr>
+                      <a:r>
+                        <a:t>Layer 5: Diagnostic Core</a:t>
+                      </a:r>
+                    </a:p>
+                  </a:txBody>
+                  <a:tcPr>
+                    <a:solidFill>
+                      <a:srgbClr val="FFFFFF"/>
+                    </a:solidFill>
+                  </a:tcPr>
+                </a:tc>
+                <a:tc>
+                  <a:txBody>
+                    <a:bodyPr/>
+                    <a:lstStyle/>
+                    <a:p>
+                      <a:pPr>
+                        <a:defRPr sz="1000" b="0">
+                          <a:solidFill>
+                            <a:srgbClr val="334155"/>
+                          </a:solidFill>
+                        </a:defRPr>
+                      </a:pPr>
+                      <a:r>
+                        <a:t>src/inference.py</a:t>
+                      </a:r>
+                    </a:p>
+                  </a:txBody>
+                  <a:tcPr>
+                    <a:solidFill>
+                      <a:srgbClr val="FFFFFF"/>
+                    </a:solidFill>
+                  </a:tcPr>
+                </a:tc>
+                <a:tc>
+                  <a:txBody>
+                    <a:bodyPr/>
+                    <a:lstStyle/>
+                    <a:p>
+                      <a:pPr>
+                        <a:defRPr sz="1000" b="1">
+                          <a:solidFill>
+                            <a:srgbClr val="0D9488"/>
+                          </a:solidFill>
+                        </a:defRPr>
+                      </a:pPr>
+                      <a:r>
+                        <a:t>✅ Completed</a:t>
+                      </a:r>
+                    </a:p>
+                  </a:txBody>
+                  <a:tcPr>
+                    <a:solidFill>
+                      <a:srgbClr val="FFFFFF"/>
+                    </a:solidFill>
+                  </a:tcPr>
+                </a:tc>
+                <a:tc>
+                  <a:txBody>
+                    <a:bodyPr/>
+                    <a:lstStyle/>
+                    <a:p>
+                      <a:pPr>
+                        <a:defRPr sz="1000" b="0">
+                          <a:solidFill>
+                            <a:srgbClr val="334155"/>
+                          </a:solidFill>
+                        </a:defRPr>
+                      </a:pPr>
+                      <a:r>
+                        <a:t>Established inference engine with dual-mode evaluation, coordinate localization, and Med-VQA.</a:t>
+                      </a:r>
+                    </a:p>
+                  </a:txBody>
+                  <a:tcPr>
+                    <a:solidFill>
+                      <a:srgbClr val="FFFFFF"/>
+                    </a:solidFill>
+                  </a:tcPr>
+                </a:tc>
+              </a:tr>
+              <a:tr h="777240">
+                <a:tc>
+                  <a:txBody>
+                    <a:bodyPr/>
+                    <a:lstStyle/>
+                    <a:p>
+                      <a:pPr>
+                        <a:defRPr sz="1000" b="1">
+                          <a:solidFill>
+                            <a:srgbClr val="334155"/>
+                          </a:solidFill>
+                        </a:defRPr>
+                      </a:pPr>
+                      <a:r>
+                        <a:t>Layer 6: Report Generator</a:t>
+                      </a:r>
+                    </a:p>
+                  </a:txBody>
+                  <a:tcPr>
+                    <a:solidFill>
+                      <a:srgbClr val="FFFFFF"/>
+                    </a:solidFill>
+                  </a:tcPr>
+                </a:tc>
+                <a:tc>
+                  <a:txBody>
+                    <a:bodyPr/>
+                    <a:lstStyle/>
+                    <a:p>
+                      <a:pPr>
+                        <a:defRPr sz="1000" b="0">
+                          <a:solidFill>
+                            <a:srgbClr val="334155"/>
+                          </a:solidFill>
+                        </a:defRPr>
+                      </a:pPr>
+                      <a:r>
+                        <a:t>src/report_generator.py</a:t>
+                      </a:r>
+                    </a:p>
+                  </a:txBody>
+                  <a:tcPr>
+                    <a:solidFill>
+                      <a:srgbClr val="FFFFFF"/>
+                    </a:solidFill>
+                  </a:tcPr>
+                </a:tc>
+                <a:tc>
+                  <a:txBody>
+                    <a:bodyPr/>
+                    <a:lstStyle/>
+                    <a:p>
+                      <a:pPr>
+                        <a:defRPr sz="1000" b="1">
+                          <a:solidFill>
+                            <a:srgbClr val="0D9488"/>
+                          </a:solidFill>
+                        </a:defRPr>
+                      </a:pPr>
+                      <a:r>
+                        <a:t>✅ Completed</a:t>
+                      </a:r>
+                    </a:p>
+                  </a:txBody>
+                  <a:tcPr>
+                    <a:solidFill>
+                      <a:srgbClr val="FFFFFF"/>
+                    </a:solidFill>
+                  </a:tcPr>
+                </a:tc>
+                <a:tc>
+                  <a:txBody>
+                    <a:bodyPr/>
+                    <a:lstStyle/>
+                    <a:p>
+                      <a:pPr>
+                        <a:defRPr sz="1000" b="0">
+                          <a:solidFill>
+                            <a:srgbClr val="334155"/>
+                          </a:solidFill>
+                        </a:defRPr>
+                      </a:pPr>
+                      <a:r>
+                        <a:t>Built automated clinical report generator producing structured text and signed PDF documents.</a:t>
+                      </a:r>
+                    </a:p>
+                  </a:txBody>
+                  <a:tcPr>
+                    <a:solidFill>
+                      <a:srgbClr val="FFFFFF"/>
+                    </a:solidFill>
+                  </a:tcPr>
+                </a:tc>
+              </a:tr>
+              <a:tr h="777240">
+                <a:tc>
+                  <a:txBody>
+                    <a:bodyPr/>
+                    <a:lstStyle/>
+                    <a:p>
+                      <a:pPr>
+                        <a:defRPr sz="1000" b="1">
+                          <a:solidFill>
+                            <a:srgbClr val="334155"/>
+                          </a:solidFill>
+                        </a:defRPr>
+                      </a:pPr>
+                      <a:r>
+                        <a:t>Layer 6: Med-VQA Web UI</a:t>
+                      </a:r>
+                    </a:p>
+                  </a:txBody>
+                  <a:tcPr>
+                    <a:solidFill>
+                      <a:srgbClr val="FFFFFF"/>
+                    </a:solidFill>
+                  </a:tcPr>
+                </a:tc>
+                <a:tc>
+                  <a:txBody>
+                    <a:bodyPr/>
+                    <a:lstStyle/>
+                    <a:p>
+                      <a:pPr>
+                        <a:defRPr sz="1000" b="0">
+                          <a:solidFill>
+                            <a:srgbClr val="334155"/>
+                          </a:solidFill>
+                        </a:defRPr>
+                      </a:pPr>
+                      <a:r>
+                        <a:t>src/app.py</a:t>
+                      </a:r>
+                    </a:p>
+                  </a:txBody>
+                  <a:tcPr>
+                    <a:solidFill>
+                      <a:srgbClr val="FFFFFF"/>
+                    </a:solidFill>
+                  </a:tcPr>
+                </a:tc>
+                <a:tc>
+                  <a:txBody>
+                    <a:bodyPr/>
+                    <a:lstStyle/>
+                    <a:p>
+                      <a:pPr>
+                        <a:defRPr sz="1000" b="1">
+                          <a:solidFill>
+                            <a:srgbClr val="0D9488"/>
+                          </a:solidFill>
+                        </a:defRPr>
+                      </a:pPr>
+                      <a:r>
+                        <a:t>✅ Completed</a:t>
+                      </a:r>
+                    </a:p>
+                  </a:txBody>
+                  <a:tcPr>
+                    <a:solidFill>
+                      <a:srgbClr val="FFFFFF"/>
+                    </a:solidFill>
+                  </a:tcPr>
+                </a:tc>
+                <a:tc>
+                  <a:txBody>
+                    <a:bodyPr/>
+                    <a:lstStyle/>
+                    <a:p>
+                      <a:pPr>
+                        <a:defRPr sz="1000" b="0">
+                          <a:solidFill>
+                            <a:srgbClr val="334155"/>
+                          </a:solidFill>
+                        </a:defRPr>
+                      </a:pPr>
+                      <a:r>
+                        <a:t>Developed interactive Gradio web application for X-ray upload, conversational VQA, and report download.</a:t>
+                      </a:r>
+                    </a:p>
+                  </a:txBody>
+                  <a:tcPr>
+                    <a:solidFill>
+                      <a:srgbClr val="FFFFFF"/>
+                    </a:solidFill>
+                  </a:tcPr>
+                </a:tc>
+              </a:tr>
+            </a:tbl>
+          </a:graphicData>
+        </a:graphic>
+      </p:graphicFrame>
     </p:spTree>
   </p:cSld>
   <p:clrMapOvr>
@@ -4239,7 +4460,7 @@
         <p:spPr>
           <a:xfrm>
             <a:off x="731520" y="365760"/>
-            <a:ext cx="7315200" cy="320040"/>
+            <a:ext cx="7772400" cy="292608"/>
           </a:xfrm>
           <a:prstGeom prst="rect">
             <a:avLst/>
@@ -4261,7 +4482,7 @@
               </a:defRPr>
             </a:pPr>
             <a:r>
-              <a:t>10. SYSTEM REQUIREMENTS</a:t>
+              <a:t>10. PROPOSED SYSTEM ARCHITECTURE</a:t>
             </a:r>
           </a:p>
         </p:txBody>
@@ -4274,7 +4495,7 @@
         </p:nvSpPr>
         <p:spPr>
           <a:xfrm>
-            <a:off x="731520" y="685800"/>
+            <a:off x="731520" y="658368"/>
             <a:ext cx="9601200" cy="594360"/>
           </a:xfrm>
           <a:prstGeom prst="rect">
@@ -4297,7 +4518,7 @@
               </a:defRPr>
             </a:pPr>
             <a:r>
-              <a:t>System &amp; Technical Specifications</a:t>
+              <a:t>Proposed Methodology &amp; System Architecture</a:t>
             </a:r>
           </a:p>
         </p:txBody>
@@ -4310,7 +4531,7 @@
         </p:nvSpPr>
         <p:spPr>
           <a:xfrm>
-            <a:off x="10789920" y="457200"/>
+            <a:off x="10789920" y="411480"/>
             <a:ext cx="685800" cy="320040"/>
           </a:xfrm>
           <a:prstGeom prst="roundRect">
@@ -4352,7 +4573,7 @@
               </a:defRPr>
             </a:pPr>
             <a:r>
-              <a:t>11/12</a:t>
+              <a:t>11/13</a:t>
             </a:r>
           </a:p>
         </p:txBody>
@@ -4366,7 +4587,7 @@
         <p:spPr>
           <a:xfrm>
             <a:off x="731520" y="1508760"/>
-            <a:ext cx="5257800" cy="4663440"/>
+            <a:ext cx="10728655" cy="694944"/>
           </a:xfrm>
           <a:prstGeom prst="roundRect">
             <a:avLst/>
@@ -4374,7 +4595,7 @@
           <a:solidFill>
             <a:srgbClr val="FFFFFF"/>
           </a:solidFill>
-          <a:ln>
+          <a:ln w="15240">
             <a:solidFill>
               <a:srgbClr val="0284C7"/>
             </a:solidFill>
@@ -4399,164 +4620,22 @@
           <a:lstStyle/>
           <a:p>
             <a:pPr algn="ctr">
-              <a:defRPr b="1" sz="1300">
+              <a:defRPr b="1" sz="1150">
                 <a:solidFill>
                   <a:srgbClr val="0284C7"/>
                 </a:solidFill>
               </a:defRPr>
             </a:pPr>
             <a:r>
-              <a:t>💻 Hardware Specifications</a:t>
-            </a:r>
-          </a:p>
-          <a:p>
-            <a:br/>
-            <a:pPr>
-              <a:defRPr b="1" sz="1050">
-                <a:solidFill>
-                  <a:srgbClr val="0F172A"/>
-                </a:solidFill>
-              </a:defRPr>
-            </a:pPr>
-            <a:r>
-              <a:t>• Primary Target Workstation:</a:t>
-            </a:r>
-          </a:p>
-          <a:p>
-            <a:pPr>
-              <a:defRPr sz="1000">
+              <a:t>Layer 1: Data Ingestion:  </a:t>
+            </a:r>
+            <a:r>
+              <a:rPr b="0" sz="1000">
                 <a:solidFill>
                   <a:srgbClr val="334155"/>
                 </a:solidFill>
-              </a:defRPr>
-            </a:pPr>
-            <a:r>
-              <a:t>  Consumer Laptop / Lab Workstation (Dell G15 / RTX 3050)</a:t>
-            </a:r>
-          </a:p>
-          <a:p>
-            <a:br/>
-            <a:pPr>
-              <a:defRPr b="1" sz="1050">
-                <a:solidFill>
-                  <a:srgbClr val="0F172A"/>
-                </a:solidFill>
-              </a:defRPr>
-            </a:pPr>
-            <a:r>
-              <a:t>• GPU VRAM Required:</a:t>
-            </a:r>
-          </a:p>
-          <a:p>
-            <a:pPr>
-              <a:defRPr sz="1000">
-                <a:solidFill>
-                  <a:srgbClr val="334155"/>
-                </a:solidFill>
-              </a:defRPr>
-            </a:pPr>
-            <a:r>
-              <a:t>  6 GB VRAM minimum for QLoRA 4-bit local training</a:t>
-            </a:r>
-          </a:p>
-          <a:p>
-            <a:br/>
-            <a:pPr>
-              <a:defRPr b="1" sz="1050">
-                <a:solidFill>
-                  <a:srgbClr val="0F172A"/>
-                </a:solidFill>
-              </a:defRPr>
-            </a:pPr>
-            <a:r>
-              <a:t>• Peak Training VRAM:</a:t>
-            </a:r>
-          </a:p>
-          <a:p>
-            <a:pPr>
-              <a:defRPr sz="1000">
-                <a:solidFill>
-                  <a:srgbClr val="334155"/>
-                </a:solidFill>
-              </a:defRPr>
-            </a:pPr>
-            <a:r>
-              <a:t>  ~3.8 GB (well within 6 GB VRAM capacity)</a:t>
-            </a:r>
-          </a:p>
-          <a:p>
-            <a:br/>
-            <a:pPr>
-              <a:defRPr b="1" sz="1050">
-                <a:solidFill>
-                  <a:srgbClr val="0F172A"/>
-                </a:solidFill>
-              </a:defRPr>
-            </a:pPr>
-            <a:r>
-              <a:t>• System RAM:</a:t>
-            </a:r>
-          </a:p>
-          <a:p>
-            <a:pPr>
-              <a:defRPr sz="1000">
-                <a:solidFill>
-                  <a:srgbClr val="334155"/>
-                </a:solidFill>
-              </a:defRPr>
-            </a:pPr>
-            <a:r>
-              <a:t>  16 GB DDR4 / DDR5 RAM</a:t>
-            </a:r>
-          </a:p>
-          <a:p>
-            <a:br/>
-            <a:pPr>
-              <a:defRPr b="1" sz="1050">
-                <a:solidFill>
-                  <a:srgbClr val="0F172A"/>
-                </a:solidFill>
-              </a:defRPr>
-            </a:pPr>
-            <a:r>
-              <a:t>• Storage Required:</a:t>
-            </a:r>
-          </a:p>
-          <a:p>
-            <a:pPr>
-              <a:defRPr sz="1000">
-                <a:solidFill>
-                  <a:srgbClr val="334155"/>
-                </a:solidFill>
-              </a:defRPr>
-            </a:pPr>
-            <a:r>
-              <a:t>  10 GB SSD space for dataset &amp; adapter weights</a:t>
-            </a:r>
-          </a:p>
-          <a:p>
-            <a:br/>
-            <a:pPr>
-              <a:defRPr b="1" sz="1050">
-                <a:solidFill>
-                  <a:srgbClr val="0F172A"/>
-                </a:solidFill>
-              </a:defRPr>
-            </a:pPr>
-            <a:r>
-              <a:t>• Cloud Benchmark Option:</a:t>
-            </a:r>
-          </a:p>
-          <a:p>
-            <a:pPr>
-              <a:defRPr sz="1000">
-                <a:solidFill>
-                  <a:srgbClr val="334155"/>
-                </a:solidFill>
-              </a:defRPr>
-            </a:pPr>
-            <a:r>
-              <a:t>  Google Colab Free Tier (NVIDIA Tesla T4 16 GB VRAM)</a:t>
+              </a:rPr>
+              <a:t>4,083 FracAtlas radiographs + COCO bounding box &amp; mask annotations (download_dataset.py)</a:t>
             </a:r>
           </a:p>
         </p:txBody>
@@ -4569,8 +4648,8 @@
         </p:nvSpPr>
         <p:spPr>
           <a:xfrm>
-            <a:off x="6172200" y="1508760"/>
-            <a:ext cx="5257800" cy="4663440"/>
+            <a:off x="731520" y="2313432"/>
+            <a:ext cx="10728655" cy="694944"/>
           </a:xfrm>
           <a:prstGeom prst="roundRect">
             <a:avLst/>
@@ -4578,9 +4657,9 @@
           <a:solidFill>
             <a:srgbClr val="FFFFFF"/>
           </a:solidFill>
-          <a:ln>
+          <a:ln w="15240">
             <a:solidFill>
-              <a:srgbClr val="0D9488"/>
+              <a:srgbClr val="0284C7"/>
             </a:solidFill>
           </a:ln>
         </p:spPr>
@@ -4603,164 +4682,270 @@
           <a:lstStyle/>
           <a:p>
             <a:pPr algn="ctr">
-              <a:defRPr b="1" sz="1300">
+              <a:defRPr b="1" sz="1150">
+                <a:solidFill>
+                  <a:srgbClr val="0284C7"/>
+                </a:solidFill>
+              </a:defRPr>
+            </a:pPr>
+            <a:r>
+              <a:t>Layer 2: Preprocessing Pipeline:  </a:t>
+            </a:r>
+            <a:r>
+              <a:rPr b="0" sz="1000">
+                <a:solidFill>
+                  <a:srgbClr val="334155"/>
+                </a:solidFill>
+              </a:rPr>
+              <a:t>1:1 balanced sampling producing 1,438 LLaVA-format conversation pairs with clinical queries (src/dataset_to_vlm.py)</a:t>
+            </a:r>
+          </a:p>
+        </p:txBody>
+      </p:sp>
+      <p:sp>
+        <p:nvSpPr>
+          <p:cNvPr id="8" name="Rounded Rectangle 7"/>
+          <p:cNvSpPr/>
+          <p:nvPr/>
+        </p:nvSpPr>
+        <p:spPr>
+          <a:xfrm>
+            <a:off x="731520" y="3118104"/>
+            <a:ext cx="10728655" cy="694944"/>
+          </a:xfrm>
+          <a:prstGeom prst="roundRect">
+            <a:avLst/>
+          </a:prstGeom>
+          <a:solidFill>
+            <a:srgbClr val="FFFFFF"/>
+          </a:solidFill>
+          <a:ln w="15240">
+            <a:solidFill>
+              <a:srgbClr val="0D9488"/>
+            </a:solidFill>
+          </a:ln>
+        </p:spPr>
+        <p:style>
+          <a:lnRef idx="1">
+            <a:schemeClr val="accent1"/>
+          </a:lnRef>
+          <a:fillRef idx="3">
+            <a:schemeClr val="accent1"/>
+          </a:fillRef>
+          <a:effectRef idx="2">
+            <a:schemeClr val="accent1"/>
+          </a:effectRef>
+          <a:fontRef idx="minor">
+            <a:schemeClr val="lt1"/>
+          </a:fontRef>
+        </p:style>
+        <p:txBody>
+          <a:bodyPr rtlCol="0" anchor="ctr" wrap="square"/>
+          <a:lstStyle/>
+          <a:p>
+            <a:pPr algn="ctr">
+              <a:defRPr b="1" sz="1150">
                 <a:solidFill>
                   <a:srgbClr val="0D9488"/>
                 </a:solidFill>
               </a:defRPr>
             </a:pPr>
             <a:r>
-              <a:t>⚙️ Software &amp; Library Stack</a:t>
-            </a:r>
-          </a:p>
-          <a:p>
-            <a:br/>
-            <a:pPr>
-              <a:defRPr b="1" sz="1050">
+              <a:t>Layer 3: Foundation VLM Baseline:  </a:t>
+            </a:r>
+            <a:r>
+              <a:rPr b="0" sz="1000">
+                <a:solidFill>
+                  <a:srgbClr val="334155"/>
+                </a:solidFill>
+              </a:rPr>
+              <a:t>Qwen2-VL-2B-Instruct multimodal backbone with dynamic-resolution Vision Transformer (ViT) &amp; M-RoPE embeddings</a:t>
+            </a:r>
+          </a:p>
+        </p:txBody>
+      </p:sp>
+      <p:sp>
+        <p:nvSpPr>
+          <p:cNvPr id="9" name="Rounded Rectangle 8"/>
+          <p:cNvSpPr/>
+          <p:nvPr/>
+        </p:nvSpPr>
+        <p:spPr>
+          <a:xfrm>
+            <a:off x="731520" y="3922776"/>
+            <a:ext cx="10728655" cy="694944"/>
+          </a:xfrm>
+          <a:prstGeom prst="roundRect">
+            <a:avLst/>
+          </a:prstGeom>
+          <a:solidFill>
+            <a:srgbClr val="FFFFFF"/>
+          </a:solidFill>
+          <a:ln w="15240">
+            <a:solidFill>
+              <a:srgbClr val="0D9488"/>
+            </a:solidFill>
+          </a:ln>
+        </p:spPr>
+        <p:style>
+          <a:lnRef idx="1">
+            <a:schemeClr val="accent1"/>
+          </a:lnRef>
+          <a:fillRef idx="3">
+            <a:schemeClr val="accent1"/>
+          </a:fillRef>
+          <a:effectRef idx="2">
+            <a:schemeClr val="accent1"/>
+          </a:effectRef>
+          <a:fontRef idx="minor">
+            <a:schemeClr val="lt1"/>
+          </a:fontRef>
+        </p:style>
+        <p:txBody>
+          <a:bodyPr rtlCol="0" anchor="ctr" wrap="square"/>
+          <a:lstStyle/>
+          <a:p>
+            <a:pPr algn="ctr">
+              <a:defRPr b="1" sz="1150">
+                <a:solidFill>
+                  <a:srgbClr val="0D9488"/>
+                </a:solidFill>
+              </a:defRPr>
+            </a:pPr>
+            <a:r>
+              <a:t>Layer 4: Parameter-Efficient Tuning:  </a:t>
+            </a:r>
+            <a:r>
+              <a:rPr b="0" sz="1000">
+                <a:solidFill>
+                  <a:srgbClr val="334155"/>
+                </a:solidFill>
+              </a:rPr>
+              <a:t>QLoRA 4-bit NormalFloat (NF4) via BitsAndBytes on attention projections (q_proj, k_proj, v_proj, o_proj)</a:t>
+            </a:r>
+          </a:p>
+        </p:txBody>
+      </p:sp>
+      <p:sp>
+        <p:nvSpPr>
+          <p:cNvPr id="10" name="Rounded Rectangle 9"/>
+          <p:cNvSpPr/>
+          <p:nvPr/>
+        </p:nvSpPr>
+        <p:spPr>
+          <a:xfrm>
+            <a:off x="731520" y="4727448"/>
+            <a:ext cx="10728655" cy="694944"/>
+          </a:xfrm>
+          <a:prstGeom prst="roundRect">
+            <a:avLst/>
+          </a:prstGeom>
+          <a:solidFill>
+            <a:srgbClr val="FFFFFF"/>
+          </a:solidFill>
+          <a:ln w="15240">
+            <a:solidFill>
+              <a:srgbClr val="0F172A"/>
+            </a:solidFill>
+          </a:ln>
+        </p:spPr>
+        <p:style>
+          <a:lnRef idx="1">
+            <a:schemeClr val="accent1"/>
+          </a:lnRef>
+          <a:fillRef idx="3">
+            <a:schemeClr val="accent1"/>
+          </a:fillRef>
+          <a:effectRef idx="2">
+            <a:schemeClr val="accent1"/>
+          </a:effectRef>
+          <a:fontRef idx="minor">
+            <a:schemeClr val="lt1"/>
+          </a:fontRef>
+        </p:style>
+        <p:txBody>
+          <a:bodyPr rtlCol="0" anchor="ctr" wrap="square"/>
+          <a:lstStyle/>
+          <a:p>
+            <a:pPr algn="ctr">
+              <a:defRPr b="1" sz="1150">
                 <a:solidFill>
                   <a:srgbClr val="0F172A"/>
                 </a:solidFill>
               </a:defRPr>
             </a:pPr>
             <a:r>
-              <a:t>• Operating System:</a:t>
-            </a:r>
-          </a:p>
-          <a:p>
-            <a:pPr>
-              <a:defRPr sz="1000">
+              <a:t>Layer 5: Diagnostic Inference Core:  </a:t>
+            </a:r>
+            <a:r>
+              <a:rPr b="0" sz="1000">
                 <a:solidFill>
                   <a:srgbClr val="334155"/>
                 </a:solidFill>
-              </a:defRPr>
-            </a:pPr>
-            <a:r>
-              <a:t>  Windows 11 / Linux (Ubuntu) / macOS</a:t>
-            </a:r>
-          </a:p>
-          <a:p>
-            <a:br/>
-            <a:pPr>
-              <a:defRPr b="1" sz="1050">
+              </a:rPr>
+              <a:t>Central inference engine executing fracture detection, coordinate localization, and routing to clinical outputs</a:t>
+            </a:r>
+          </a:p>
+        </p:txBody>
+      </p:sp>
+      <p:sp>
+        <p:nvSpPr>
+          <p:cNvPr id="11" name="Rounded Rectangle 10"/>
+          <p:cNvSpPr/>
+          <p:nvPr/>
+        </p:nvSpPr>
+        <p:spPr>
+          <a:xfrm>
+            <a:off x="731520" y="5532120"/>
+            <a:ext cx="10728655" cy="694944"/>
+          </a:xfrm>
+          <a:prstGeom prst="roundRect">
+            <a:avLst/>
+          </a:prstGeom>
+          <a:solidFill>
+            <a:srgbClr val="FFFFFF"/>
+          </a:solidFill>
+          <a:ln w="15240">
+            <a:solidFill>
+              <a:srgbClr val="0F172A"/>
+            </a:solidFill>
+          </a:ln>
+        </p:spPr>
+        <p:style>
+          <a:lnRef idx="1">
+            <a:schemeClr val="accent1"/>
+          </a:lnRef>
+          <a:fillRef idx="3">
+            <a:schemeClr val="accent1"/>
+          </a:fillRef>
+          <a:effectRef idx="2">
+            <a:schemeClr val="accent1"/>
+          </a:effectRef>
+          <a:fontRef idx="minor">
+            <a:schemeClr val="lt1"/>
+          </a:fontRef>
+        </p:style>
+        <p:txBody>
+          <a:bodyPr rtlCol="0" anchor="ctr" wrap="square"/>
+          <a:lstStyle/>
+          <a:p>
+            <a:pPr algn="ctr">
+              <a:defRPr b="1" sz="1150">
                 <a:solidFill>
                   <a:srgbClr val="0F172A"/>
                 </a:solidFill>
               </a:defRPr>
             </a:pPr>
             <a:r>
-              <a:t>• Programming Language:</a:t>
-            </a:r>
-          </a:p>
-          <a:p>
-            <a:pPr>
-              <a:defRPr sz="1000">
+              <a:t>Layer 6: System Outputs &amp; Interfaces:  </a:t>
+            </a:r>
+            <a:r>
+              <a:rPr b="0" sz="1000">
                 <a:solidFill>
                   <a:srgbClr val="334155"/>
                 </a:solidFill>
-              </a:defRPr>
-            </a:pPr>
-            <a:r>
-              <a:t>  Python 3.10+</a:t>
-            </a:r>
-          </a:p>
-          <a:p>
-            <a:br/>
-            <a:pPr>
-              <a:defRPr b="1" sz="1050">
-                <a:solidFill>
-                  <a:srgbClr val="0F172A"/>
-                </a:solidFill>
-              </a:defRPr>
-            </a:pPr>
-            <a:r>
-              <a:t>• Deep Learning Framework:</a:t>
-            </a:r>
-          </a:p>
-          <a:p>
-            <a:pPr>
-              <a:defRPr sz="1000">
-                <a:solidFill>
-                  <a:srgbClr val="334155"/>
-                </a:solidFill>
-              </a:defRPr>
-            </a:pPr>
-            <a:r>
-              <a:t>  PyTorch 2.2+, CUDA 12.1, Torchvision</a:t>
-            </a:r>
-          </a:p>
-          <a:p>
-            <a:br/>
-            <a:pPr>
-              <a:defRPr b="1" sz="1050">
-                <a:solidFill>
-                  <a:srgbClr val="0F172A"/>
-                </a:solidFill>
-              </a:defRPr>
-            </a:pPr>
-            <a:r>
-              <a:t>• Transformers &amp; Models:</a:t>
-            </a:r>
-          </a:p>
-          <a:p>
-            <a:pPr>
-              <a:defRPr sz="1000">
-                <a:solidFill>
-                  <a:srgbClr val="334155"/>
-                </a:solidFill>
-              </a:defRPr>
-            </a:pPr>
-            <a:r>
-              <a:t>  HuggingFace Transformers 4.42+, Accelerate</a:t>
-            </a:r>
-          </a:p>
-          <a:p>
-            <a:br/>
-            <a:pPr>
-              <a:defRPr b="1" sz="1050">
-                <a:solidFill>
-                  <a:srgbClr val="0F172A"/>
-                </a:solidFill>
-              </a:defRPr>
-            </a:pPr>
-            <a:r>
-              <a:t>• Quantization &amp; PEFT:</a:t>
-            </a:r>
-          </a:p>
-          <a:p>
-            <a:pPr>
-              <a:defRPr sz="1000">
-                <a:solidFill>
-                  <a:srgbClr val="334155"/>
-                </a:solidFill>
-              </a:defRPr>
-            </a:pPr>
-            <a:r>
-              <a:t>  BitsAndBytes 0.43+ (4-bit NF4), PEFT 0.11+ (LoRA)</a:t>
-            </a:r>
-          </a:p>
-          <a:p>
-            <a:br/>
-            <a:pPr>
-              <a:defRPr b="1" sz="1050">
-                <a:solidFill>
-                  <a:srgbClr val="0F172A"/>
-                </a:solidFill>
-              </a:defRPr>
-            </a:pPr>
-            <a:r>
-              <a:t>• UI &amp; PDF Authoring:</a:t>
-            </a:r>
-          </a:p>
-          <a:p>
-            <a:pPr>
-              <a:defRPr sz="1000">
-                <a:solidFill>
-                  <a:srgbClr val="334155"/>
-                </a:solidFill>
-              </a:defRPr>
-            </a:pPr>
-            <a:r>
-              <a:t>  Gradio 4.32+ (WebUI), ReportLab 4.1+ (PDF reports)</a:t>
+              </a:rPr>
+              <a:t>Interactive Gradio Med-VQA Chat UI (src/app.py) + Automated ACR Clinical Radiology PDF Reports</a:t>
             </a:r>
           </a:p>
         </p:txBody>
@@ -4835,7 +5020,7 @@
         <p:spPr>
           <a:xfrm>
             <a:off x="731520" y="365760"/>
-            <a:ext cx="7315200" cy="320040"/>
+            <a:ext cx="7772400" cy="292608"/>
           </a:xfrm>
           <a:prstGeom prst="rect">
             <a:avLst/>
@@ -4857,7 +5042,7 @@
               </a:defRPr>
             </a:pPr>
             <a:r>
-              <a:t>11. TIMELINE &amp; MILESTONES</a:t>
+              <a:t>11. SYSTEM REQUIREMENTS</a:t>
             </a:r>
           </a:p>
         </p:txBody>
@@ -4870,7 +5055,7 @@
         </p:nvSpPr>
         <p:spPr>
           <a:xfrm>
-            <a:off x="731520" y="685800"/>
+            <a:off x="731520" y="658368"/>
             <a:ext cx="9601200" cy="594360"/>
           </a:xfrm>
           <a:prstGeom prst="rect">
@@ -4893,7 +5078,7 @@
               </a:defRPr>
             </a:pPr>
             <a:r>
-              <a:t>Project Roadmap &amp; Semester Plan</a:t>
+              <a:t>System &amp; Technical Specifications</a:t>
             </a:r>
           </a:p>
         </p:txBody>
@@ -4906,7 +5091,7 @@
         </p:nvSpPr>
         <p:spPr>
           <a:xfrm>
-            <a:off x="10789920" y="457200"/>
+            <a:off x="10789920" y="411480"/>
             <a:ext cx="685800" cy="320040"/>
           </a:xfrm>
           <a:prstGeom prst="roundRect">
@@ -4948,7 +5133,603 @@
               </a:defRPr>
             </a:pPr>
             <a:r>
-              <a:t>12/12</a:t>
+              <a:t>12/13</a:t>
+            </a:r>
+          </a:p>
+        </p:txBody>
+      </p:sp>
+      <p:sp>
+        <p:nvSpPr>
+          <p:cNvPr id="6" name="Rounded Rectangle 5"/>
+          <p:cNvSpPr/>
+          <p:nvPr/>
+        </p:nvSpPr>
+        <p:spPr>
+          <a:xfrm>
+            <a:off x="731520" y="1508760"/>
+            <a:ext cx="5257800" cy="4663440"/>
+          </a:xfrm>
+          <a:prstGeom prst="roundRect">
+            <a:avLst/>
+          </a:prstGeom>
+          <a:solidFill>
+            <a:srgbClr val="FFFFFF"/>
+          </a:solidFill>
+          <a:ln>
+            <a:solidFill>
+              <a:srgbClr val="0284C7"/>
+            </a:solidFill>
+          </a:ln>
+        </p:spPr>
+        <p:style>
+          <a:lnRef idx="1">
+            <a:schemeClr val="accent1"/>
+          </a:lnRef>
+          <a:fillRef idx="3">
+            <a:schemeClr val="accent1"/>
+          </a:fillRef>
+          <a:effectRef idx="2">
+            <a:schemeClr val="accent1"/>
+          </a:effectRef>
+          <a:fontRef idx="minor">
+            <a:schemeClr val="lt1"/>
+          </a:fontRef>
+        </p:style>
+        <p:txBody>
+          <a:bodyPr rtlCol="0" anchor="ctr" wrap="square"/>
+          <a:lstStyle/>
+          <a:p>
+            <a:pPr algn="ctr">
+              <a:defRPr b="1" sz="1300">
+                <a:solidFill>
+                  <a:srgbClr val="0284C7"/>
+                </a:solidFill>
+              </a:defRPr>
+            </a:pPr>
+            <a:r>
+              <a:t>💻 Hardware Specifications</a:t>
+            </a:r>
+          </a:p>
+          <a:p>
+            <a:br/>
+            <a:pPr>
+              <a:defRPr b="1" sz="1050">
+                <a:solidFill>
+                  <a:srgbClr val="0F172A"/>
+                </a:solidFill>
+              </a:defRPr>
+            </a:pPr>
+            <a:r>
+              <a:t>• Primary Target Workstation:</a:t>
+            </a:r>
+          </a:p>
+          <a:p>
+            <a:pPr>
+              <a:defRPr sz="1000">
+                <a:solidFill>
+                  <a:srgbClr val="334155"/>
+                </a:solidFill>
+              </a:defRPr>
+            </a:pPr>
+            <a:r>
+              <a:t>  Consumer Laptop / Lab Workstation (Dell G15 / RTX 3050)</a:t>
+            </a:r>
+          </a:p>
+          <a:p>
+            <a:br/>
+            <a:pPr>
+              <a:defRPr b="1" sz="1050">
+                <a:solidFill>
+                  <a:srgbClr val="0F172A"/>
+                </a:solidFill>
+              </a:defRPr>
+            </a:pPr>
+            <a:r>
+              <a:t>• GPU VRAM Required:</a:t>
+            </a:r>
+          </a:p>
+          <a:p>
+            <a:pPr>
+              <a:defRPr sz="1000">
+                <a:solidFill>
+                  <a:srgbClr val="334155"/>
+                </a:solidFill>
+              </a:defRPr>
+            </a:pPr>
+            <a:r>
+              <a:t>  6 GB VRAM minimum for QLoRA 4-bit local training</a:t>
+            </a:r>
+          </a:p>
+          <a:p>
+            <a:br/>
+            <a:pPr>
+              <a:defRPr b="1" sz="1050">
+                <a:solidFill>
+                  <a:srgbClr val="0F172A"/>
+                </a:solidFill>
+              </a:defRPr>
+            </a:pPr>
+            <a:r>
+              <a:t>• Peak Training VRAM:</a:t>
+            </a:r>
+          </a:p>
+          <a:p>
+            <a:pPr>
+              <a:defRPr sz="1000">
+                <a:solidFill>
+                  <a:srgbClr val="334155"/>
+                </a:solidFill>
+              </a:defRPr>
+            </a:pPr>
+            <a:r>
+              <a:t>  ~3.8 GB (well within 6 GB VRAM capacity)</a:t>
+            </a:r>
+          </a:p>
+          <a:p>
+            <a:br/>
+            <a:pPr>
+              <a:defRPr b="1" sz="1050">
+                <a:solidFill>
+                  <a:srgbClr val="0F172A"/>
+                </a:solidFill>
+              </a:defRPr>
+            </a:pPr>
+            <a:r>
+              <a:t>• System RAM:</a:t>
+            </a:r>
+          </a:p>
+          <a:p>
+            <a:pPr>
+              <a:defRPr sz="1000">
+                <a:solidFill>
+                  <a:srgbClr val="334155"/>
+                </a:solidFill>
+              </a:defRPr>
+            </a:pPr>
+            <a:r>
+              <a:t>  16 GB DDR4 / DDR5 RAM</a:t>
+            </a:r>
+          </a:p>
+          <a:p>
+            <a:br/>
+            <a:pPr>
+              <a:defRPr b="1" sz="1050">
+                <a:solidFill>
+                  <a:srgbClr val="0F172A"/>
+                </a:solidFill>
+              </a:defRPr>
+            </a:pPr>
+            <a:r>
+              <a:t>• Storage Required:</a:t>
+            </a:r>
+          </a:p>
+          <a:p>
+            <a:pPr>
+              <a:defRPr sz="1000">
+                <a:solidFill>
+                  <a:srgbClr val="334155"/>
+                </a:solidFill>
+              </a:defRPr>
+            </a:pPr>
+            <a:r>
+              <a:t>  10 GB SSD space for dataset &amp; adapter weights</a:t>
+            </a:r>
+          </a:p>
+          <a:p>
+            <a:br/>
+            <a:pPr>
+              <a:defRPr b="1" sz="1050">
+                <a:solidFill>
+                  <a:srgbClr val="0F172A"/>
+                </a:solidFill>
+              </a:defRPr>
+            </a:pPr>
+            <a:r>
+              <a:t>• Cloud Benchmark Option:</a:t>
+            </a:r>
+          </a:p>
+          <a:p>
+            <a:pPr>
+              <a:defRPr sz="1000">
+                <a:solidFill>
+                  <a:srgbClr val="334155"/>
+                </a:solidFill>
+              </a:defRPr>
+            </a:pPr>
+            <a:r>
+              <a:t>  Google Colab Free Tier (NVIDIA Tesla T4 16 GB VRAM)</a:t>
+            </a:r>
+          </a:p>
+        </p:txBody>
+      </p:sp>
+      <p:sp>
+        <p:nvSpPr>
+          <p:cNvPr id="7" name="Rounded Rectangle 6"/>
+          <p:cNvSpPr/>
+          <p:nvPr/>
+        </p:nvSpPr>
+        <p:spPr>
+          <a:xfrm>
+            <a:off x="6172200" y="1508760"/>
+            <a:ext cx="5257800" cy="4663440"/>
+          </a:xfrm>
+          <a:prstGeom prst="roundRect">
+            <a:avLst/>
+          </a:prstGeom>
+          <a:solidFill>
+            <a:srgbClr val="FFFFFF"/>
+          </a:solidFill>
+          <a:ln>
+            <a:solidFill>
+              <a:srgbClr val="0D9488"/>
+            </a:solidFill>
+          </a:ln>
+        </p:spPr>
+        <p:style>
+          <a:lnRef idx="1">
+            <a:schemeClr val="accent1"/>
+          </a:lnRef>
+          <a:fillRef idx="3">
+            <a:schemeClr val="accent1"/>
+          </a:fillRef>
+          <a:effectRef idx="2">
+            <a:schemeClr val="accent1"/>
+          </a:effectRef>
+          <a:fontRef idx="minor">
+            <a:schemeClr val="lt1"/>
+          </a:fontRef>
+        </p:style>
+        <p:txBody>
+          <a:bodyPr rtlCol="0" anchor="ctr" wrap="square"/>
+          <a:lstStyle/>
+          <a:p>
+            <a:pPr algn="ctr">
+              <a:defRPr b="1" sz="1300">
+                <a:solidFill>
+                  <a:srgbClr val="0D9488"/>
+                </a:solidFill>
+              </a:defRPr>
+            </a:pPr>
+            <a:r>
+              <a:t>⚙️ Software &amp; Library Stack</a:t>
+            </a:r>
+          </a:p>
+          <a:p>
+            <a:br/>
+            <a:pPr>
+              <a:defRPr b="1" sz="1050">
+                <a:solidFill>
+                  <a:srgbClr val="0F172A"/>
+                </a:solidFill>
+              </a:defRPr>
+            </a:pPr>
+            <a:r>
+              <a:t>• Operating System:</a:t>
+            </a:r>
+          </a:p>
+          <a:p>
+            <a:pPr>
+              <a:defRPr sz="1000">
+                <a:solidFill>
+                  <a:srgbClr val="334155"/>
+                </a:solidFill>
+              </a:defRPr>
+            </a:pPr>
+            <a:r>
+              <a:t>  Windows 11 / Linux (Ubuntu) / macOS</a:t>
+            </a:r>
+          </a:p>
+          <a:p>
+            <a:br/>
+            <a:pPr>
+              <a:defRPr b="1" sz="1050">
+                <a:solidFill>
+                  <a:srgbClr val="0F172A"/>
+                </a:solidFill>
+              </a:defRPr>
+            </a:pPr>
+            <a:r>
+              <a:t>• Programming Language:</a:t>
+            </a:r>
+          </a:p>
+          <a:p>
+            <a:pPr>
+              <a:defRPr sz="1000">
+                <a:solidFill>
+                  <a:srgbClr val="334155"/>
+                </a:solidFill>
+              </a:defRPr>
+            </a:pPr>
+            <a:r>
+              <a:t>  Python 3.10+</a:t>
+            </a:r>
+          </a:p>
+          <a:p>
+            <a:br/>
+            <a:pPr>
+              <a:defRPr b="1" sz="1050">
+                <a:solidFill>
+                  <a:srgbClr val="0F172A"/>
+                </a:solidFill>
+              </a:defRPr>
+            </a:pPr>
+            <a:r>
+              <a:t>• Deep Learning Framework:</a:t>
+            </a:r>
+          </a:p>
+          <a:p>
+            <a:pPr>
+              <a:defRPr sz="1000">
+                <a:solidFill>
+                  <a:srgbClr val="334155"/>
+                </a:solidFill>
+              </a:defRPr>
+            </a:pPr>
+            <a:r>
+              <a:t>  PyTorch 2.2+, CUDA 12.1, Torchvision</a:t>
+            </a:r>
+          </a:p>
+          <a:p>
+            <a:br/>
+            <a:pPr>
+              <a:defRPr b="1" sz="1050">
+                <a:solidFill>
+                  <a:srgbClr val="0F172A"/>
+                </a:solidFill>
+              </a:defRPr>
+            </a:pPr>
+            <a:r>
+              <a:t>• Transformers &amp; Models:</a:t>
+            </a:r>
+          </a:p>
+          <a:p>
+            <a:pPr>
+              <a:defRPr sz="1000">
+                <a:solidFill>
+                  <a:srgbClr val="334155"/>
+                </a:solidFill>
+              </a:defRPr>
+            </a:pPr>
+            <a:r>
+              <a:t>  HuggingFace Transformers 4.42+, Accelerate</a:t>
+            </a:r>
+          </a:p>
+          <a:p>
+            <a:br/>
+            <a:pPr>
+              <a:defRPr b="1" sz="1050">
+                <a:solidFill>
+                  <a:srgbClr val="0F172A"/>
+                </a:solidFill>
+              </a:defRPr>
+            </a:pPr>
+            <a:r>
+              <a:t>• Quantization &amp; PEFT:</a:t>
+            </a:r>
+          </a:p>
+          <a:p>
+            <a:pPr>
+              <a:defRPr sz="1000">
+                <a:solidFill>
+                  <a:srgbClr val="334155"/>
+                </a:solidFill>
+              </a:defRPr>
+            </a:pPr>
+            <a:r>
+              <a:t>  BitsAndBytes 0.43+ (4-bit NF4), PEFT 0.11+ (LoRA)</a:t>
+            </a:r>
+          </a:p>
+          <a:p>
+            <a:br/>
+            <a:pPr>
+              <a:defRPr b="1" sz="1050">
+                <a:solidFill>
+                  <a:srgbClr val="0F172A"/>
+                </a:solidFill>
+              </a:defRPr>
+            </a:pPr>
+            <a:r>
+              <a:t>• UI &amp; PDF Authoring:</a:t>
+            </a:r>
+          </a:p>
+          <a:p>
+            <a:pPr>
+              <a:defRPr sz="1000">
+                <a:solidFill>
+                  <a:srgbClr val="334155"/>
+                </a:solidFill>
+              </a:defRPr>
+            </a:pPr>
+            <a:r>
+              <a:t>  Gradio 4.32+ (WebUI), ReportLab 4.1+ (PDF reports)</a:t>
+            </a:r>
+          </a:p>
+        </p:txBody>
+      </p:sp>
+    </p:spTree>
+  </p:cSld>
+  <p:clrMapOvr>
+    <a:masterClrMapping/>
+  </p:clrMapOvr>
+</p:sld>
+</file>
+
+<file path=ppt/slides/slide13.xml><?xml version="1.0" encoding="utf-8"?>
+<p:sld xmlns:a="http://schemas.openxmlformats.org/drawingml/2006/main" xmlns:p="http://schemas.openxmlformats.org/presentationml/2006/main" xmlns:r="http://schemas.openxmlformats.org/officeDocument/2006/relationships">
+  <p:cSld>
+    <p:spTree>
+      <p:nvGrpSpPr>
+        <p:cNvPr id="1" name=""/>
+        <p:cNvGrpSpPr/>
+        <p:nvPr/>
+      </p:nvGrpSpPr>
+      <p:grpSpPr/>
+      <p:sp>
+        <p:nvSpPr>
+          <p:cNvPr id="2" name="Rectangle 1"/>
+          <p:cNvSpPr/>
+          <p:nvPr/>
+        </p:nvSpPr>
+        <p:spPr>
+          <a:xfrm>
+            <a:off x="0" y="0"/>
+            <a:ext cx="12191695" cy="6858000"/>
+          </a:xfrm>
+          <a:prstGeom prst="rect">
+            <a:avLst/>
+          </a:prstGeom>
+          <a:solidFill>
+            <a:srgbClr val="F8FAFC"/>
+          </a:solidFill>
+          <a:ln>
+            <a:noFill/>
+          </a:ln>
+        </p:spPr>
+        <p:style>
+          <a:lnRef idx="1">
+            <a:schemeClr val="accent1"/>
+          </a:lnRef>
+          <a:fillRef idx="3">
+            <a:schemeClr val="accent1"/>
+          </a:fillRef>
+          <a:effectRef idx="2">
+            <a:schemeClr val="accent1"/>
+          </a:effectRef>
+          <a:fontRef idx="minor">
+            <a:schemeClr val="lt1"/>
+          </a:fontRef>
+        </p:style>
+        <p:txBody>
+          <a:bodyPr rtlCol="0" anchor="ctr"/>
+          <a:lstStyle/>
+          <a:p>
+            <a:pPr algn="ctr"/>
+          </a:p>
+        </p:txBody>
+      </p:sp>
+      <p:sp>
+        <p:nvSpPr>
+          <p:cNvPr id="3" name="TextBox 2"/>
+          <p:cNvSpPr txBox="1"/>
+          <p:nvPr/>
+        </p:nvSpPr>
+        <p:spPr>
+          <a:xfrm>
+            <a:off x="731520" y="365760"/>
+            <a:ext cx="7772400" cy="292608"/>
+          </a:xfrm>
+          <a:prstGeom prst="rect">
+            <a:avLst/>
+          </a:prstGeom>
+          <a:noFill/>
+        </p:spPr>
+        <p:txBody>
+          <a:bodyPr wrap="square" lIns="0" tIns="0" rIns="0" bIns="0">
+            <a:spAutoFit/>
+          </a:bodyPr>
+          <a:lstStyle/>
+          <a:p>
+            <a:pPr>
+              <a:defRPr sz="1000" b="1">
+                <a:solidFill>
+                  <a:srgbClr val="0284C7"/>
+                </a:solidFill>
+                <a:latin typeface="Arial"/>
+              </a:defRPr>
+            </a:pPr>
+            <a:r>
+              <a:t>12. TIMELINE &amp; MILESTONES</a:t>
+            </a:r>
+          </a:p>
+        </p:txBody>
+      </p:sp>
+      <p:sp>
+        <p:nvSpPr>
+          <p:cNvPr id="4" name="TextBox 3"/>
+          <p:cNvSpPr txBox="1"/>
+          <p:nvPr/>
+        </p:nvSpPr>
+        <p:spPr>
+          <a:xfrm>
+            <a:off x="731520" y="658368"/>
+            <a:ext cx="9601200" cy="594360"/>
+          </a:xfrm>
+          <a:prstGeom prst="rect">
+            <a:avLst/>
+          </a:prstGeom>
+          <a:noFill/>
+        </p:spPr>
+        <p:txBody>
+          <a:bodyPr wrap="square" lIns="0" tIns="0" rIns="0" bIns="0">
+            <a:spAutoFit/>
+          </a:bodyPr>
+          <a:lstStyle/>
+          <a:p>
+            <a:pPr>
+              <a:defRPr sz="2200" b="1">
+                <a:solidFill>
+                  <a:srgbClr val="0F172A"/>
+                </a:solidFill>
+                <a:latin typeface="Arial"/>
+              </a:defRPr>
+            </a:pPr>
+            <a:r>
+              <a:t>Project Roadmap &amp; Semester Plan</a:t>
+            </a:r>
+          </a:p>
+        </p:txBody>
+      </p:sp>
+      <p:sp>
+        <p:nvSpPr>
+          <p:cNvPr id="5" name="Rounded Rectangle 4"/>
+          <p:cNvSpPr/>
+          <p:nvPr/>
+        </p:nvSpPr>
+        <p:spPr>
+          <a:xfrm>
+            <a:off x="10789920" y="411480"/>
+            <a:ext cx="685800" cy="320040"/>
+          </a:xfrm>
+          <a:prstGeom prst="roundRect">
+            <a:avLst/>
+          </a:prstGeom>
+          <a:solidFill>
+            <a:srgbClr val="FFFFFF"/>
+          </a:solidFill>
+          <a:ln w="12700">
+            <a:solidFill>
+              <a:srgbClr val="E2E8F0"/>
+            </a:solidFill>
+          </a:ln>
+        </p:spPr>
+        <p:style>
+          <a:lnRef idx="1">
+            <a:schemeClr val="accent1"/>
+          </a:lnRef>
+          <a:fillRef idx="3">
+            <a:schemeClr val="accent1"/>
+          </a:fillRef>
+          <a:effectRef idx="2">
+            <a:schemeClr val="accent1"/>
+          </a:effectRef>
+          <a:fontRef idx="minor">
+            <a:schemeClr val="lt1"/>
+          </a:fontRef>
+        </p:style>
+        <p:txBody>
+          <a:bodyPr rtlCol="0" anchor="ctr"/>
+          <a:lstStyle/>
+          <a:p>
+            <a:pPr algn="ctr">
+              <a:defRPr sz="1000" b="1">
+                <a:solidFill>
+                  <a:srgbClr val="64748B"/>
+                </a:solidFill>
+                <a:latin typeface="Arial"/>
+              </a:defRPr>
+            </a:pPr>
+            <a:r>
+              <a:t>13/13</a:t>
             </a:r>
           </a:p>
         </p:txBody>
@@ -5317,7 +6098,7 @@
         <p:spPr>
           <a:xfrm>
             <a:off x="731520" y="365760"/>
-            <a:ext cx="7315200" cy="320040"/>
+            <a:ext cx="7772400" cy="292608"/>
           </a:xfrm>
           <a:prstGeom prst="rect">
             <a:avLst/>
@@ -5352,7 +6133,7 @@
         </p:nvSpPr>
         <p:spPr>
           <a:xfrm>
-            <a:off x="731520" y="685800"/>
+            <a:off x="731520" y="658368"/>
             <a:ext cx="9601200" cy="594360"/>
           </a:xfrm>
           <a:prstGeom prst="rect">
@@ -5388,7 +6169,7 @@
         </p:nvSpPr>
         <p:spPr>
           <a:xfrm>
-            <a:off x="10789920" y="457200"/>
+            <a:off x="10789920" y="411480"/>
             <a:ext cx="685800" cy="320040"/>
           </a:xfrm>
           <a:prstGeom prst="roundRect">
@@ -5430,7 +6211,7 @@
               </a:defRPr>
             </a:pPr>
             <a:r>
-              <a:t>2/12</a:t>
+              <a:t>2/13</a:t>
             </a:r>
           </a:p>
         </p:txBody>
@@ -5496,7 +6277,7 @@
               </a:defRPr>
             </a:pPr>
             <a:r>
-              <a:t>• Radiography (X-Ray) is the primary first-line imaging modality for trauma emergencies.</a:t>
+              <a:t>• First-Line Modality: Digital projection radiography (X-ray) is the standard initial imaging modality for trauma emergencies.</a:t>
             </a:r>
           </a:p>
           <a:p>
@@ -5508,7 +6289,7 @@
               </a:defRPr>
             </a:pPr>
             <a:r>
-              <a:t>• High daily imaging volume in emergency wards creates severe diagnostic burdens on radiologists.</a:t>
+              <a:t>• High Clinical Volume: Over 60% of all emergency imaging consists of musculoskeletal radiographs.</a:t>
             </a:r>
           </a:p>
           <a:p>
@@ -5520,7 +6301,7 @@
               </a:defRPr>
             </a:pPr>
             <a:r>
-              <a:t>• Accurate, timely detection of bone fractures is vital to prevent long-term limb disability.</a:t>
+              <a:t>• Diagnostic Pressure: Emergency doctors must make rapid triage decisions under intense time pressure.</a:t>
             </a:r>
           </a:p>
         </p:txBody>
@@ -5598,7 +6379,7 @@
               </a:defRPr>
             </a:pPr>
             <a:r>
-              <a:t>• 2nd Gen: Deep CNNs (ResNet, DenseNet, YOLO) outputting bounding boxes without textual explanation.</a:t>
+              <a:t>• 2nd Gen: Deep CNNs (ResNet, YOLO) outputting bounding boxes without textual explanation.</a:t>
             </a:r>
           </a:p>
           <a:p>
@@ -5610,7 +6391,7 @@
               </a:defRPr>
             </a:pPr>
             <a:r>
-              <a:t>• 3rd Gen (Current): Vision-Language Models (VLMs) that integrate visual perception with natural language reasoning.</a:t>
+              <a:t>• 3rd Gen (Current): Multimodal Vision-Language Models (VLMs) that integrate visual perception with natural clinical language.</a:t>
             </a:r>
           </a:p>
         </p:txBody>
@@ -5676,7 +6457,7 @@
               </a:defRPr>
             </a:pPr>
             <a:r>
-              <a:t>• Combines a Vision Encoder (processes X-ray pixels) with a Large Language Model (generates clinical dialogue).</a:t>
+              <a:t>• Combines a Vision Transformer (processes X-ray pixels) with a Large Language Model (generates clinical dialogue).</a:t>
             </a:r>
           </a:p>
           <a:p>
@@ -5775,7 +6556,7 @@
         <p:spPr>
           <a:xfrm>
             <a:off x="731520" y="365760"/>
-            <a:ext cx="7315200" cy="320040"/>
+            <a:ext cx="7772400" cy="292608"/>
           </a:xfrm>
           <a:prstGeom prst="rect">
             <a:avLst/>
@@ -5810,7 +6591,7 @@
         </p:nvSpPr>
         <p:spPr>
           <a:xfrm>
-            <a:off x="731520" y="685800"/>
+            <a:off x="731520" y="658368"/>
             <a:ext cx="9601200" cy="594360"/>
           </a:xfrm>
           <a:prstGeom prst="rect">
@@ -5846,7 +6627,7 @@
         </p:nvSpPr>
         <p:spPr>
           <a:xfrm>
-            <a:off x="10789920" y="457200"/>
+            <a:off x="10789920" y="411480"/>
             <a:ext cx="685800" cy="320040"/>
           </a:xfrm>
           <a:prstGeom prst="roundRect">
@@ -5888,7 +6669,7 @@
               </a:defRPr>
             </a:pPr>
             <a:r>
-              <a:t>3/12</a:t>
+              <a:t>3/13</a:t>
             </a:r>
           </a:p>
         </p:txBody>
@@ -5954,7 +6735,7 @@
               </a:defRPr>
             </a:pPr>
             <a:r>
-              <a:t>• Severe shortage of radiologists during night shifts and emergency triage hours.</a:t>
+              <a:t>• Severe shortage of specialized radiologists during night shifts and peak trauma hours.</a:t>
             </a:r>
           </a:p>
           <a:p>
@@ -5966,7 +6747,7 @@
               </a:defRPr>
             </a:pPr>
             <a:r>
-              <a:t>• Initial radiographs are routinely interpreted by non-radiologist junior doctors.</a:t>
+              <a:t>• Initial radiographs are routinely interpreted by non-radiologist junior emergency doctors.</a:t>
             </a:r>
           </a:p>
           <a:p>
@@ -5978,7 +6759,7 @@
               </a:defRPr>
             </a:pPr>
             <a:r>
-              <a:t>• Time delays in trauma assessment directly affect surgical management windows.</a:t>
+              <a:t>• Turnaround delays directly impact emergency stabilization and orthopedic surgery.</a:t>
             </a:r>
           </a:p>
         </p:txBody>
@@ -6044,7 +6825,7 @@
               </a:defRPr>
             </a:pPr>
             <a:r>
-              <a:t>• Clinical audits confirm missed fractures constitute up to 80% of diagnostic emergency room errors.</a:t>
+              <a:t>• Clinical literature confirms missed fractures account for up to 80% of emergency diagnostic errors.</a:t>
             </a:r>
           </a:p>
           <a:p>
@@ -6068,7 +6849,7 @@
               </a:defRPr>
             </a:pPr>
             <a:r>
-              <a:t>• Delayed diagnosis causes non-union, chronic pain, and avoidable joint arthrosis.</a:t>
+              <a:t>• Delayed diagnosis causes permanent bone malunion, chronic pain, and avoidable arthrosis.</a:t>
             </a:r>
           </a:p>
         </p:txBody>
@@ -6134,7 +6915,7 @@
               </a:defRPr>
             </a:pPr>
             <a:r>
-              <a:t>• Existing CAD/CNN tools provide only raw bounding boxes or binary heatmaps.</a:t>
+              <a:t>• Traditional CNN detectors (ResNet, YOLO) output only raw bounding boxes or binary heatmaps.</a:t>
             </a:r>
           </a:p>
           <a:p>
@@ -6146,7 +6927,7 @@
               </a:defRPr>
             </a:pPr>
             <a:r>
-              <a:t>• Doctors cannot ask questions (e.g. 'Is there displacement?' or 'Is fixation hardware present?').</a:t>
+              <a:t>• Mute systems: doctors cannot ask questions (e.g. 'Is there displacement?' or 'Is hardware present?').</a:t>
             </a:r>
           </a:p>
           <a:p>
@@ -6224,7 +7005,7 @@
               </a:defRPr>
             </a:pPr>
             <a:r>
-              <a:t>• Point-of-care second-reader assistant operating in real time (&lt; 2 seconds).</a:t>
+              <a:t>• Point-of-care assistive second-reader operating in real time (&lt; 2 seconds per scan).</a:t>
             </a:r>
           </a:p>
           <a:p>
@@ -6323,7 +7104,7 @@
         <p:spPr>
           <a:xfrm>
             <a:off x="731520" y="365760"/>
-            <a:ext cx="7315200" cy="320040"/>
+            <a:ext cx="7772400" cy="292608"/>
           </a:xfrm>
           <a:prstGeom prst="rect">
             <a:avLst/>
@@ -6358,7 +7139,7 @@
         </p:nvSpPr>
         <p:spPr>
           <a:xfrm>
-            <a:off x="731520" y="685800"/>
+            <a:off x="731520" y="658368"/>
             <a:ext cx="9601200" cy="594360"/>
           </a:xfrm>
           <a:prstGeom prst="rect">
@@ -6394,7 +7175,7 @@
         </p:nvSpPr>
         <p:spPr>
           <a:xfrm>
-            <a:off x="10789920" y="457200"/>
+            <a:off x="10789920" y="411480"/>
             <a:ext cx="685800" cy="320040"/>
           </a:xfrm>
           <a:prstGeom prst="roundRect">
@@ -6436,7 +7217,7 @@
               </a:defRPr>
             </a:pPr>
             <a:r>
-              <a:t>4/12</a:t>
+              <a:t>4/13</a:t>
             </a:r>
           </a:p>
         </p:txBody>
@@ -6781,7 +7562,7 @@
         <p:spPr>
           <a:xfrm>
             <a:off x="731520" y="365760"/>
-            <a:ext cx="7315200" cy="320040"/>
+            <a:ext cx="7772400" cy="292608"/>
           </a:xfrm>
           <a:prstGeom prst="rect">
             <a:avLst/>
@@ -6816,7 +7597,7 @@
         </p:nvSpPr>
         <p:spPr>
           <a:xfrm>
-            <a:off x="731520" y="685800"/>
+            <a:off x="731520" y="658368"/>
             <a:ext cx="9601200" cy="594360"/>
           </a:xfrm>
           <a:prstGeom prst="rect">
@@ -6852,7 +7633,7 @@
         </p:nvSpPr>
         <p:spPr>
           <a:xfrm>
-            <a:off x="10789920" y="457200"/>
+            <a:off x="10789920" y="411480"/>
             <a:ext cx="685800" cy="320040"/>
           </a:xfrm>
           <a:prstGeom prst="roundRect">
@@ -6894,7 +7675,7 @@
               </a:defRPr>
             </a:pPr>
             <a:r>
-              <a:t>5/12</a:t>
+              <a:t>5/13</a:t>
             </a:r>
           </a:p>
         </p:txBody>
@@ -7201,7 +7982,7 @@
                         </a:defRPr>
                       </a:pPr>
                       <a:r>
-                        <a:t>Curated dataset release.</a:t>
+                        <a:t>Curated benchmark dataset.</a:t>
                       </a:r>
                     </a:p>
                     <a:p>
@@ -7320,7 +8101,7 @@
                     </a:p>
                     <a:p>
                       <a:r>
-                        <a:t>Tuned on biomedical QA pairs.</a:t>
+                        <a:t>Instruction-tuned on biomedical QA pairs.</a:t>
                       </a:r>
                     </a:p>
                   </a:txBody>
@@ -7542,7 +8323,7 @@
         <p:spPr>
           <a:xfrm>
             <a:off x="731520" y="365760"/>
-            <a:ext cx="7315200" cy="320040"/>
+            <a:ext cx="7772400" cy="292608"/>
           </a:xfrm>
           <a:prstGeom prst="rect">
             <a:avLst/>
@@ -7577,7 +8358,7 @@
         </p:nvSpPr>
         <p:spPr>
           <a:xfrm>
-            <a:off x="731520" y="685800"/>
+            <a:off x="731520" y="658368"/>
             <a:ext cx="9601200" cy="594360"/>
           </a:xfrm>
           <a:prstGeom prst="rect">
@@ -7600,7 +8381,7 @@
               </a:defRPr>
             </a:pPr>
             <a:r>
-              <a:t>Research Gaps &amp; Proposed Novelty</a:t>
+              <a:t>Research Gaps &amp; Proposed Approach</a:t>
             </a:r>
           </a:p>
         </p:txBody>
@@ -7613,7 +8394,7 @@
         </p:nvSpPr>
         <p:spPr>
           <a:xfrm>
-            <a:off x="10789920" y="457200"/>
+            <a:off x="10789920" y="411480"/>
             <a:ext cx="685800" cy="320040"/>
           </a:xfrm>
           <a:prstGeom prst="roundRect">
@@ -7655,7 +8436,7 @@
               </a:defRPr>
             </a:pPr>
             <a:r>
-              <a:t>6/12</a:t>
+              <a:t>6/13</a:t>
             </a:r>
           </a:p>
         </p:txBody>
@@ -7799,7 +8580,7 @@
               </a:defRPr>
             </a:pPr>
             <a:r>
-              <a:t>• Existing fracture detection tools (YOLO, Faster R-CNN) only output boxes or heatmaps.</a:t>
+              <a:t>• Existing fracture detection tools (YOLO, Faster R-CNN) only output raw coordinates or heatmaps.</a:t>
             </a:r>
           </a:p>
           <a:p>
@@ -7964,7 +8745,7 @@
         <p:spPr>
           <a:xfrm>
             <a:off x="731520" y="365760"/>
-            <a:ext cx="7315200" cy="320040"/>
+            <a:ext cx="7772400" cy="292608"/>
           </a:xfrm>
           <a:prstGeom prst="rect">
             <a:avLst/>
@@ -7999,7 +8780,7 @@
         </p:nvSpPr>
         <p:spPr>
           <a:xfrm>
-            <a:off x="731520" y="685800"/>
+            <a:off x="731520" y="658368"/>
             <a:ext cx="9601200" cy="594360"/>
           </a:xfrm>
           <a:prstGeom prst="rect">
@@ -8022,7 +8803,7 @@
               </a:defRPr>
             </a:pPr>
             <a:r>
-              <a:t>Project Objectives &amp; Deliverables</a:t>
+              <a:t>Project Objectives &amp; Key Deliverables</a:t>
             </a:r>
           </a:p>
         </p:txBody>
@@ -8035,7 +8816,7 @@
         </p:nvSpPr>
         <p:spPr>
           <a:xfrm>
-            <a:off x="10789920" y="457200"/>
+            <a:off x="10789920" y="411480"/>
             <a:ext cx="685800" cy="320040"/>
           </a:xfrm>
           <a:prstGeom prst="roundRect">
@@ -8077,7 +8858,7 @@
               </a:defRPr>
             </a:pPr>
             <a:r>
-              <a:t>7/12</a:t>
+              <a:t>7/13</a:t>
             </a:r>
           </a:p>
         </p:txBody>
@@ -8416,7 +9197,7 @@
         <p:spPr>
           <a:xfrm>
             <a:off x="731520" y="365760"/>
-            <a:ext cx="7315200" cy="320040"/>
+            <a:ext cx="7772400" cy="292608"/>
           </a:xfrm>
           <a:prstGeom prst="rect">
             <a:avLst/>
@@ -8438,7 +9219,7 @@
               </a:defRPr>
             </a:pPr>
             <a:r>
-              <a:t>7. DATASET EXPLORATION</a:t>
+              <a:t>7. DATASET INGESTION</a:t>
             </a:r>
           </a:p>
         </p:txBody>
@@ -8451,7 +9232,7 @@
         </p:nvSpPr>
         <p:spPr>
           <a:xfrm>
-            <a:off x="731520" y="685800"/>
+            <a:off x="731520" y="658368"/>
             <a:ext cx="9601200" cy="594360"/>
           </a:xfrm>
           <a:prstGeom prst="rect">
@@ -8474,7 +9255,7 @@
               </a:defRPr>
             </a:pPr>
             <a:r>
-              <a:t>Dataset Description &amp; Demographics (FracAtlas)</a:t>
+              <a:t>Layer 1: Dataset Description &amp; Exploration (FracAtlas)</a:t>
             </a:r>
           </a:p>
         </p:txBody>
@@ -8487,7 +9268,7 @@
         </p:nvSpPr>
         <p:spPr>
           <a:xfrm>
-            <a:off x="10789920" y="457200"/>
+            <a:off x="10789920" y="411480"/>
             <a:ext cx="685800" cy="320040"/>
           </a:xfrm>
           <a:prstGeom prst="roundRect">
@@ -8529,7 +9310,7 @@
               </a:defRPr>
             </a:pPr>
             <a:r>
-              <a:t>8/12</a:t>
+              <a:t>8/13</a:t>
             </a:r>
           </a:p>
         </p:txBody>
@@ -8943,7 +9724,7 @@
               </a:defRPr>
             </a:pPr>
             <a:r>
-              <a:t>• Annotation Formats: COCO bounding boxes, segmentation masks, YOLO, VOC</a:t>
+              <a:t>• Multi-Format Ground Truth: COCO masks, YOLO, Pascal VOC, VGG</a:t>
             </a:r>
           </a:p>
         </p:txBody>
@@ -8997,7 +9778,7 @@
               </a:defRPr>
             </a:pPr>
             <a:r>
-              <a:t>⚠️ Class Imbalance &amp; Preprocessing Challenge</a:t>
+              <a:t>⚠️ Class Imbalance &amp; Ingestion Automation</a:t>
             </a:r>
           </a:p>
           <a:p>
@@ -9021,7 +9802,7 @@
               </a:defRPr>
             </a:pPr>
             <a:r>
-              <a:t>• Training Danger: Unbalanced training causes models to predict 'Normal' for all scans, achieving 82% accuracy with zero clinical sensitivity.</a:t>
+              <a:t>• Training Risk: Unbalanced training causes models to predict 'Normal' for all scans, achieving 82% accuracy with 0% clinical sensitivity.</a:t>
             </a:r>
           </a:p>
           <a:p>
@@ -9033,7 +9814,7 @@
               </a:defRPr>
             </a:pPr>
             <a:r>
-              <a:t>• Mitigation: Handled via 1:1 balanced negative control sampling in dataset_to_vlm.py.</a:t>
+              <a:t>• Ingestion Script: download_dataset.py automatically fetches archive, verifies MD5 checksum, and structures folders while preserving clean Git bounds.</a:t>
             </a:r>
           </a:p>
         </p:txBody>
@@ -9108,7 +9889,7 @@
         <p:spPr>
           <a:xfrm>
             <a:off x="731520" y="365760"/>
-            <a:ext cx="7315200" cy="320040"/>
+            <a:ext cx="7772400" cy="292608"/>
           </a:xfrm>
           <a:prstGeom prst="rect">
             <a:avLst/>
@@ -9130,7 +9911,7 @@
               </a:defRPr>
             </a:pPr>
             <a:r>
-              <a:t>8. CURRENT PROGRESS</a:t>
+              <a:t>8. DATA PREPROCESSING PIPELINE</a:t>
             </a:r>
           </a:p>
         </p:txBody>
@@ -9143,7 +9924,7 @@
         </p:nvSpPr>
         <p:spPr>
           <a:xfrm>
-            <a:off x="731520" y="685800"/>
+            <a:off x="731520" y="658368"/>
             <a:ext cx="9601200" cy="594360"/>
           </a:xfrm>
           <a:prstGeom prst="rect">
@@ -9166,7 +9947,7 @@
               </a:defRPr>
             </a:pPr>
             <a:r>
-              <a:t>Work Done So Far (Review 1 Deliverables)</a:t>
+              <a:t>Layer 2: Preprocessing Pipeline (src/dataset_to_vlm.py)</a:t>
             </a:r>
           </a:p>
         </p:txBody>
@@ -9179,7 +9960,7 @@
         </p:nvSpPr>
         <p:spPr>
           <a:xfrm>
-            <a:off x="10789920" y="457200"/>
+            <a:off x="10789920" y="411480"/>
             <a:ext cx="685800" cy="320040"/>
           </a:xfrm>
           <a:prstGeom prst="roundRect">
@@ -9221,603 +10002,494 @@
               </a:defRPr>
             </a:pPr>
             <a:r>
-              <a:t>9/12</a:t>
-            </a:r>
-          </a:p>
-        </p:txBody>
-      </p:sp>
-      <p:graphicFrame>
-        <p:nvGraphicFramePr>
-          <p:cNvPr id="6" name="Table 5"/>
-          <p:cNvGraphicFramePr>
-            <a:graphicFrameLocks noGrp="1"/>
-          </p:cNvGraphicFramePr>
+              <a:t>9/13</a:t>
+            </a:r>
+          </a:p>
+        </p:txBody>
+      </p:sp>
+      <p:sp>
+        <p:nvSpPr>
+          <p:cNvPr id="6" name="Rounded Rectangle 5"/>
+          <p:cNvSpPr/>
           <p:nvPr/>
-        </p:nvGraphicFramePr>
-        <p:xfrm>
-          <a:off x="731520" y="1508760"/>
-          <a:ext cx="10728655" cy="4663440"/>
-        </p:xfrm>
-        <a:graphic>
-          <a:graphicData uri="http://schemas.openxmlformats.org/drawingml/2006/table">
-            <a:tbl>
-              <a:tblPr firstRow="1" bandRow="1">
-                <a:tableStyleId>{5C22544A-7EE6-4342-B048-85BDC9FD1C3A}</a:tableStyleId>
-              </a:tblPr>
-              <a:tblGrid>
-                <a:gridCol w="2011680"/>
-                <a:gridCol w="2103120"/>
-                <a:gridCol w="1645920"/>
-                <a:gridCol w="4967935"/>
-              </a:tblGrid>
-              <a:tr h="777240">
-                <a:tc>
-                  <a:txBody>
-                    <a:bodyPr/>
-                    <a:lstStyle/>
-                    <a:p>
-                      <a:pPr>
-                        <a:defRPr b="1" sz="1050">
-                          <a:solidFill>
-                            <a:srgbClr val="FFFFFF"/>
-                          </a:solidFill>
-                        </a:defRPr>
-                      </a:pPr>
-                      <a:r>
-                        <a:t>Milestone Task</a:t>
-                      </a:r>
-                    </a:p>
-                  </a:txBody>
-                  <a:tcPr>
-                    <a:solidFill>
-                      <a:srgbClr val="0F172A"/>
-                    </a:solidFill>
-                  </a:tcPr>
-                </a:tc>
-                <a:tc>
-                  <a:txBody>
-                    <a:bodyPr/>
-                    <a:lstStyle/>
-                    <a:p>
-                      <a:pPr>
-                        <a:defRPr b="1" sz="1050">
-                          <a:solidFill>
-                            <a:srgbClr val="FFFFFF"/>
-                          </a:solidFill>
-                        </a:defRPr>
-                      </a:pPr>
-                      <a:r>
-                        <a:t>Associated File</a:t>
-                      </a:r>
-                    </a:p>
-                  </a:txBody>
-                  <a:tcPr>
-                    <a:solidFill>
-                      <a:srgbClr val="0F172A"/>
-                    </a:solidFill>
-                  </a:tcPr>
-                </a:tc>
-                <a:tc>
-                  <a:txBody>
-                    <a:bodyPr/>
-                    <a:lstStyle/>
-                    <a:p>
-                      <a:pPr>
-                        <a:defRPr b="1" sz="1050">
-                          <a:solidFill>
-                            <a:srgbClr val="FFFFFF"/>
-                          </a:solidFill>
-                        </a:defRPr>
-                      </a:pPr>
-                      <a:r>
-                        <a:t>Review 1 Status</a:t>
-                      </a:r>
-                    </a:p>
-                  </a:txBody>
-                  <a:tcPr>
-                    <a:solidFill>
-                      <a:srgbClr val="0F172A"/>
-                    </a:solidFill>
-                  </a:tcPr>
-                </a:tc>
-                <a:tc>
-                  <a:txBody>
-                    <a:bodyPr/>
-                    <a:lstStyle/>
-                    <a:p>
-                      <a:pPr>
-                        <a:defRPr b="1" sz="1050">
-                          <a:solidFill>
-                            <a:srgbClr val="FFFFFF"/>
-                          </a:solidFill>
-                        </a:defRPr>
-                      </a:pPr>
-                      <a:r>
-                        <a:t>Output &amp; Completed Deliverable</a:t>
-                      </a:r>
-                    </a:p>
-                  </a:txBody>
-                  <a:tcPr>
-                    <a:solidFill>
-                      <a:srgbClr val="0F172A"/>
-                    </a:solidFill>
-                  </a:tcPr>
-                </a:tc>
-              </a:tr>
-              <a:tr h="777240">
-                <a:tc>
-                  <a:txBody>
-                    <a:bodyPr/>
-                    <a:lstStyle/>
-                    <a:p>
-                      <a:pPr>
-                        <a:defRPr sz="1000" b="1">
-                          <a:solidFill>
-                            <a:srgbClr val="334155"/>
-                          </a:solidFill>
-                        </a:defRPr>
-                      </a:pPr>
-                      <a:r>
-                        <a:t>Dataset Ingestion</a:t>
-                      </a:r>
-                    </a:p>
-                  </a:txBody>
-                  <a:tcPr>
-                    <a:solidFill>
-                      <a:srgbClr val="FFFFFF"/>
-                    </a:solidFill>
-                  </a:tcPr>
-                </a:tc>
-                <a:tc>
-                  <a:txBody>
-                    <a:bodyPr/>
-                    <a:lstStyle/>
-                    <a:p>
-                      <a:pPr>
-                        <a:defRPr sz="1000" b="0">
-                          <a:solidFill>
-                            <a:srgbClr val="334155"/>
-                          </a:solidFill>
-                        </a:defRPr>
-                      </a:pPr>
-                      <a:r>
-                        <a:t>download_dataset.py</a:t>
-                      </a:r>
-                    </a:p>
-                  </a:txBody>
-                  <a:tcPr>
-                    <a:solidFill>
-                      <a:srgbClr val="FFFFFF"/>
-                    </a:solidFill>
-                  </a:tcPr>
-                </a:tc>
-                <a:tc>
-                  <a:txBody>
-                    <a:bodyPr/>
-                    <a:lstStyle/>
-                    <a:p>
-                      <a:pPr>
-                        <a:defRPr sz="1000" b="1">
-                          <a:solidFill>
-                            <a:srgbClr val="0D9488"/>
-                          </a:solidFill>
-                        </a:defRPr>
-                      </a:pPr>
-                      <a:r>
-                        <a:t>✅ Completed</a:t>
-                      </a:r>
-                    </a:p>
-                  </a:txBody>
-                  <a:tcPr>
-                    <a:solidFill>
-                      <a:srgbClr val="FFFFFF"/>
-                    </a:solidFill>
-                  </a:tcPr>
-                </a:tc>
-                <a:tc>
-                  <a:txBody>
-                    <a:bodyPr/>
-                    <a:lstStyle/>
-                    <a:p>
-                      <a:pPr>
-                        <a:defRPr sz="1000" b="0">
-                          <a:solidFill>
-                            <a:srgbClr val="334155"/>
-                          </a:solidFill>
-                        </a:defRPr>
-                      </a:pPr>
-                      <a:r>
-                        <a:t>Automated script fetching, verifying MD5 checksum, and extracting 4,083 scans.</a:t>
-                      </a:r>
-                    </a:p>
-                  </a:txBody>
-                  <a:tcPr>
-                    <a:solidFill>
-                      <a:srgbClr val="FFFFFF"/>
-                    </a:solidFill>
-                  </a:tcPr>
-                </a:tc>
-              </a:tr>
-              <a:tr h="777240">
-                <a:tc>
-                  <a:txBody>
-                    <a:bodyPr/>
-                    <a:lstStyle/>
-                    <a:p>
-                      <a:pPr>
-                        <a:defRPr sz="1000" b="1">
-                          <a:solidFill>
-                            <a:srgbClr val="334155"/>
-                          </a:solidFill>
-                        </a:defRPr>
-                      </a:pPr>
-                      <a:r>
-                        <a:t>Data Preprocessing</a:t>
-                      </a:r>
-                    </a:p>
-                  </a:txBody>
-                  <a:tcPr>
-                    <a:solidFill>
-                      <a:srgbClr val="FFFFFF"/>
-                    </a:solidFill>
-                  </a:tcPr>
-                </a:tc>
-                <a:tc>
-                  <a:txBody>
-                    <a:bodyPr/>
-                    <a:lstStyle/>
-                    <a:p>
-                      <a:pPr>
-                        <a:defRPr sz="1000" b="0">
-                          <a:solidFill>
-                            <a:srgbClr val="334155"/>
-                          </a:solidFill>
-                        </a:defRPr>
-                      </a:pPr>
-                      <a:r>
-                        <a:t>src/dataset_to_vlm.py</a:t>
-                      </a:r>
-                    </a:p>
-                  </a:txBody>
-                  <a:tcPr>
-                    <a:solidFill>
-                      <a:srgbClr val="FFFFFF"/>
-                    </a:solidFill>
-                  </a:tcPr>
-                </a:tc>
-                <a:tc>
-                  <a:txBody>
-                    <a:bodyPr/>
-                    <a:lstStyle/>
-                    <a:p>
-                      <a:pPr>
-                        <a:defRPr sz="1000" b="1">
-                          <a:solidFill>
-                            <a:srgbClr val="0D9488"/>
-                          </a:solidFill>
-                        </a:defRPr>
-                      </a:pPr>
-                      <a:r>
-                        <a:t>✅ Completed</a:t>
-                      </a:r>
-                    </a:p>
-                  </a:txBody>
-                  <a:tcPr>
-                    <a:solidFill>
-                      <a:srgbClr val="FFFFFF"/>
-                    </a:solidFill>
-                  </a:tcPr>
-                </a:tc>
-                <a:tc>
-                  <a:txBody>
-                    <a:bodyPr/>
-                    <a:lstStyle/>
-                    <a:p>
-                      <a:pPr>
-                        <a:defRPr sz="1000" b="0">
-                          <a:solidFill>
-                            <a:srgbClr val="334155"/>
-                          </a:solidFill>
-                        </a:defRPr>
-                      </a:pPr>
-                      <a:r>
-                        <a:t>Enforced 1:1 balanced sampling; created 1,438 LLaVA dialogue pairs (train: 1,148, val: 164, test: 126).</a:t>
-                      </a:r>
-                    </a:p>
-                  </a:txBody>
-                  <a:tcPr>
-                    <a:solidFill>
-                      <a:srgbClr val="FFFFFF"/>
-                    </a:solidFill>
-                  </a:tcPr>
-                </a:tc>
-              </a:tr>
-              <a:tr h="777240">
-                <a:tc>
-                  <a:txBody>
-                    <a:bodyPr/>
-                    <a:lstStyle/>
-                    <a:p>
-                      <a:pPr>
-                        <a:defRPr sz="1000" b="1">
-                          <a:solidFill>
-                            <a:srgbClr val="334155"/>
-                          </a:solidFill>
-                        </a:defRPr>
-                      </a:pPr>
-                      <a:r>
-                        <a:t>Baseline Scaffolding</a:t>
-                      </a:r>
-                    </a:p>
-                  </a:txBody>
-                  <a:tcPr>
-                    <a:solidFill>
-                      <a:srgbClr val="FFFFFF"/>
-                    </a:solidFill>
-                  </a:tcPr>
-                </a:tc>
-                <a:tc>
-                  <a:txBody>
-                    <a:bodyPr/>
-                    <a:lstStyle/>
-                    <a:p>
-                      <a:pPr>
-                        <a:defRPr sz="1000" b="0">
-                          <a:solidFill>
-                            <a:srgbClr val="334155"/>
-                          </a:solidFill>
-                        </a:defRPr>
-                      </a:pPr>
-                      <a:r>
-                        <a:t>src/inference.py</a:t>
-                      </a:r>
-                    </a:p>
-                  </a:txBody>
-                  <a:tcPr>
-                    <a:solidFill>
-                      <a:srgbClr val="FFFFFF"/>
-                    </a:solidFill>
-                  </a:tcPr>
-                </a:tc>
-                <a:tc>
-                  <a:txBody>
-                    <a:bodyPr/>
-                    <a:lstStyle/>
-                    <a:p>
-                      <a:pPr>
-                        <a:defRPr sz="1000" b="1">
-                          <a:solidFill>
-                            <a:srgbClr val="0D9488"/>
-                          </a:solidFill>
-                        </a:defRPr>
-                      </a:pPr>
-                      <a:r>
-                        <a:t>✅ Completed</a:t>
-                      </a:r>
-                    </a:p>
-                  </a:txBody>
-                  <a:tcPr>
-                    <a:solidFill>
-                      <a:srgbClr val="FFFFFF"/>
-                    </a:solidFill>
-                  </a:tcPr>
-                </a:tc>
-                <a:tc>
-                  <a:txBody>
-                    <a:bodyPr/>
-                    <a:lstStyle/>
-                    <a:p>
-                      <a:pPr>
-                        <a:defRPr sz="1000" b="0">
-                          <a:solidFill>
-                            <a:srgbClr val="334155"/>
-                          </a:solidFill>
-                        </a:defRPr>
-                      </a:pPr>
-                      <a:r>
-                        <a:t>Established inference engine with dual-mode evaluation and coordinate localization.</a:t>
-                      </a:r>
-                    </a:p>
-                  </a:txBody>
-                  <a:tcPr>
-                    <a:solidFill>
-                      <a:srgbClr val="FFFFFF"/>
-                    </a:solidFill>
-                  </a:tcPr>
-                </a:tc>
-              </a:tr>
-              <a:tr h="777240">
-                <a:tc>
-                  <a:txBody>
-                    <a:bodyPr/>
-                    <a:lstStyle/>
-                    <a:p>
-                      <a:pPr>
-                        <a:defRPr sz="1000" b="1">
-                          <a:solidFill>
-                            <a:srgbClr val="334155"/>
-                          </a:solidFill>
-                        </a:defRPr>
-                      </a:pPr>
-                      <a:r>
-                        <a:t>Reporting Engine</a:t>
-                      </a:r>
-                    </a:p>
-                  </a:txBody>
-                  <a:tcPr>
-                    <a:solidFill>
-                      <a:srgbClr val="FFFFFF"/>
-                    </a:solidFill>
-                  </a:tcPr>
-                </a:tc>
-                <a:tc>
-                  <a:txBody>
-                    <a:bodyPr/>
-                    <a:lstStyle/>
-                    <a:p>
-                      <a:pPr>
-                        <a:defRPr sz="1000" b="0">
-                          <a:solidFill>
-                            <a:srgbClr val="334155"/>
-                          </a:solidFill>
-                        </a:defRPr>
-                      </a:pPr>
-                      <a:r>
-                        <a:t>src/report_generator.py</a:t>
-                      </a:r>
-                    </a:p>
-                  </a:txBody>
-                  <a:tcPr>
-                    <a:solidFill>
-                      <a:srgbClr val="FFFFFF"/>
-                    </a:solidFill>
-                  </a:tcPr>
-                </a:tc>
-                <a:tc>
-                  <a:txBody>
-                    <a:bodyPr/>
-                    <a:lstStyle/>
-                    <a:p>
-                      <a:pPr>
-                        <a:defRPr sz="1000" b="1">
-                          <a:solidFill>
-                            <a:srgbClr val="0D9488"/>
-                          </a:solidFill>
-                        </a:defRPr>
-                      </a:pPr>
-                      <a:r>
-                        <a:t>✅ Completed</a:t>
-                      </a:r>
-                    </a:p>
-                  </a:txBody>
-                  <a:tcPr>
-                    <a:solidFill>
-                      <a:srgbClr val="FFFFFF"/>
-                    </a:solidFill>
-                  </a:tcPr>
-                </a:tc>
-                <a:tc>
-                  <a:txBody>
-                    <a:bodyPr/>
-                    <a:lstStyle/>
-                    <a:p>
-                      <a:pPr>
-                        <a:defRPr sz="1000" b="0">
-                          <a:solidFill>
-                            <a:srgbClr val="334155"/>
-                          </a:solidFill>
-                        </a:defRPr>
-                      </a:pPr>
-                      <a:r>
-                        <a:t>Built automated clinical report generator producing structured text and signed PDF documents.</a:t>
-                      </a:r>
-                    </a:p>
-                  </a:txBody>
-                  <a:tcPr>
-                    <a:solidFill>
-                      <a:srgbClr val="FFFFFF"/>
-                    </a:solidFill>
-                  </a:tcPr>
-                </a:tc>
-              </a:tr>
-              <a:tr h="777240">
-                <a:tc>
-                  <a:txBody>
-                    <a:bodyPr/>
-                    <a:lstStyle/>
-                    <a:p>
-                      <a:pPr>
-                        <a:defRPr sz="1000" b="1">
-                          <a:solidFill>
-                            <a:srgbClr val="334155"/>
-                          </a:solidFill>
-                        </a:defRPr>
-                      </a:pPr>
-                      <a:r>
-                        <a:t>Med-VQA Interface</a:t>
-                      </a:r>
-                    </a:p>
-                  </a:txBody>
-                  <a:tcPr>
-                    <a:solidFill>
-                      <a:srgbClr val="FFFFFF"/>
-                    </a:solidFill>
-                  </a:tcPr>
-                </a:tc>
-                <a:tc>
-                  <a:txBody>
-                    <a:bodyPr/>
-                    <a:lstStyle/>
-                    <a:p>
-                      <a:pPr>
-                        <a:defRPr sz="1000" b="0">
-                          <a:solidFill>
-                            <a:srgbClr val="334155"/>
-                          </a:solidFill>
-                        </a:defRPr>
-                      </a:pPr>
-                      <a:r>
-                        <a:t>src/app.py</a:t>
-                      </a:r>
-                    </a:p>
-                  </a:txBody>
-                  <a:tcPr>
-                    <a:solidFill>
-                      <a:srgbClr val="FFFFFF"/>
-                    </a:solidFill>
-                  </a:tcPr>
-                </a:tc>
-                <a:tc>
-                  <a:txBody>
-                    <a:bodyPr/>
-                    <a:lstStyle/>
-                    <a:p>
-                      <a:pPr>
-                        <a:defRPr sz="1000" b="1">
-                          <a:solidFill>
-                            <a:srgbClr val="0D9488"/>
-                          </a:solidFill>
-                        </a:defRPr>
-                      </a:pPr>
-                      <a:r>
-                        <a:t>✅ Completed</a:t>
-                      </a:r>
-                    </a:p>
-                  </a:txBody>
-                  <a:tcPr>
-                    <a:solidFill>
-                      <a:srgbClr val="FFFFFF"/>
-                    </a:solidFill>
-                  </a:tcPr>
-                </a:tc>
-                <a:tc>
-                  <a:txBody>
-                    <a:bodyPr/>
-                    <a:lstStyle/>
-                    <a:p>
-                      <a:pPr>
-                        <a:defRPr sz="1000" b="0">
-                          <a:solidFill>
-                            <a:srgbClr val="334155"/>
-                          </a:solidFill>
-                        </a:defRPr>
-                      </a:pPr>
-                      <a:r>
-                        <a:t>Developed interactive Gradio web application for X-ray upload, conversational VQA, and report download.</a:t>
-                      </a:r>
-                    </a:p>
-                  </a:txBody>
-                  <a:tcPr>
-                    <a:solidFill>
-                      <a:srgbClr val="FFFFFF"/>
-                    </a:solidFill>
-                  </a:tcPr>
-                </a:tc>
-              </a:tr>
-            </a:tbl>
-          </a:graphicData>
-        </a:graphic>
-      </p:graphicFrame>
+        </p:nvSpPr>
+        <p:spPr>
+          <a:xfrm>
+            <a:off x="731520" y="1508760"/>
+            <a:ext cx="3456432" cy="2103120"/>
+          </a:xfrm>
+          <a:prstGeom prst="roundRect">
+            <a:avLst/>
+          </a:prstGeom>
+          <a:solidFill>
+            <a:srgbClr val="FFFFFF"/>
+          </a:solidFill>
+          <a:ln w="19050">
+            <a:solidFill>
+              <a:srgbClr val="0284C7"/>
+            </a:solidFill>
+          </a:ln>
+        </p:spPr>
+        <p:style>
+          <a:lnRef idx="1">
+            <a:schemeClr val="accent1"/>
+          </a:lnRef>
+          <a:fillRef idx="3">
+            <a:schemeClr val="accent1"/>
+          </a:fillRef>
+          <a:effectRef idx="2">
+            <a:schemeClr val="accent1"/>
+          </a:effectRef>
+          <a:fontRef idx="minor">
+            <a:schemeClr val="lt1"/>
+          </a:fontRef>
+        </p:style>
+        <p:txBody>
+          <a:bodyPr rtlCol="0" anchor="ctr" wrap="square"/>
+          <a:lstStyle/>
+          <a:p>
+            <a:pPr algn="ctr">
+              <a:defRPr b="1" sz="1150">
+                <a:solidFill>
+                  <a:srgbClr val="0284C7"/>
+                </a:solidFill>
+              </a:defRPr>
+            </a:pPr>
+            <a:r>
+              <a:t>Step 1: Annotation Parsing</a:t>
+            </a:r>
+          </a:p>
+          <a:p>
+            <a:pPr>
+              <a:defRPr sz="950">
+                <a:solidFill>
+                  <a:srgbClr val="334155"/>
+                </a:solidFill>
+              </a:defRPr>
+            </a:pPr>
+            <a:r>
+              <a:t>• Reads raw dataset.csv &amp; split CSVs.</a:t>
+            </a:r>
+          </a:p>
+          <a:p>
+            <a:pPr>
+              <a:defRPr sz="950">
+                <a:solidFill>
+                  <a:srgbClr val="334155"/>
+                </a:solidFill>
+              </a:defRPr>
+            </a:pPr>
+            <a:r>
+              <a:t>• Parses COCO_fracture_masks.json.</a:t>
+            </a:r>
+          </a:p>
+          <a:p>
+            <a:pPr>
+              <a:defRPr sz="950">
+                <a:solidFill>
+                  <a:srgbClr val="334155"/>
+                </a:solidFill>
+              </a:defRPr>
+            </a:pPr>
+            <a:r>
+              <a:t>• Extracts precise bounding coordinates [x1, y1, x2, y2] for each cortical fracture.</a:t>
+            </a:r>
+          </a:p>
+        </p:txBody>
+      </p:sp>
+      <p:sp>
+        <p:nvSpPr>
+          <p:cNvPr id="7" name="Rounded Rectangle 6"/>
+          <p:cNvSpPr/>
+          <p:nvPr/>
+        </p:nvSpPr>
+        <p:spPr>
+          <a:xfrm>
+            <a:off x="4370832" y="1508760"/>
+            <a:ext cx="3456432" cy="2103120"/>
+          </a:xfrm>
+          <a:prstGeom prst="roundRect">
+            <a:avLst/>
+          </a:prstGeom>
+          <a:solidFill>
+            <a:srgbClr val="FFFFFF"/>
+          </a:solidFill>
+          <a:ln w="19050">
+            <a:solidFill>
+              <a:srgbClr val="D97706"/>
+            </a:solidFill>
+          </a:ln>
+        </p:spPr>
+        <p:style>
+          <a:lnRef idx="1">
+            <a:schemeClr val="accent1"/>
+          </a:lnRef>
+          <a:fillRef idx="3">
+            <a:schemeClr val="accent1"/>
+          </a:fillRef>
+          <a:effectRef idx="2">
+            <a:schemeClr val="accent1"/>
+          </a:effectRef>
+          <a:fontRef idx="minor">
+            <a:schemeClr val="lt1"/>
+          </a:fontRef>
+        </p:style>
+        <p:txBody>
+          <a:bodyPr rtlCol="0" anchor="ctr" wrap="square"/>
+          <a:lstStyle/>
+          <a:p>
+            <a:pPr algn="ctr">
+              <a:defRPr b="1" sz="1150">
+                <a:solidFill>
+                  <a:srgbClr val="D97706"/>
+                </a:solidFill>
+              </a:defRPr>
+            </a:pPr>
+            <a:r>
+              <a:t>Step 2: 1:1 Balanced Sampling</a:t>
+            </a:r>
+          </a:p>
+          <a:p>
+            <a:pPr>
+              <a:defRPr sz="950">
+                <a:solidFill>
+                  <a:srgbClr val="334155"/>
+                </a:solidFill>
+              </a:defRPr>
+            </a:pPr>
+            <a:r>
+              <a:t>• Eliminates 82% normal control skew.</a:t>
+            </a:r>
+          </a:p>
+          <a:p>
+            <a:pPr>
+              <a:defRPr sz="950">
+                <a:solidFill>
+                  <a:srgbClr val="334155"/>
+                </a:solidFill>
+              </a:defRPr>
+            </a:pPr>
+            <a:r>
+              <a:t>• Pairs each fractured scan with an anatomically matched normal control.</a:t>
+            </a:r>
+          </a:p>
+          <a:p>
+            <a:pPr>
+              <a:defRPr sz="950">
+                <a:solidFill>
+                  <a:srgbClr val="334155"/>
+                </a:solidFill>
+              </a:defRPr>
+            </a:pPr>
+            <a:r>
+              <a:t>• Prevents the VLM from learning majority-class prediction bias.</a:t>
+            </a:r>
+          </a:p>
+        </p:txBody>
+      </p:sp>
+      <p:sp>
+        <p:nvSpPr>
+          <p:cNvPr id="8" name="Rounded Rectangle 7"/>
+          <p:cNvSpPr/>
+          <p:nvPr/>
+        </p:nvSpPr>
+        <p:spPr>
+          <a:xfrm>
+            <a:off x="8010144" y="1508760"/>
+            <a:ext cx="3456432" cy="2103120"/>
+          </a:xfrm>
+          <a:prstGeom prst="roundRect">
+            <a:avLst/>
+          </a:prstGeom>
+          <a:solidFill>
+            <a:srgbClr val="FFFFFF"/>
+          </a:solidFill>
+          <a:ln w="19050">
+            <a:solidFill>
+              <a:srgbClr val="0D9488"/>
+            </a:solidFill>
+          </a:ln>
+        </p:spPr>
+        <p:style>
+          <a:lnRef idx="1">
+            <a:schemeClr val="accent1"/>
+          </a:lnRef>
+          <a:fillRef idx="3">
+            <a:schemeClr val="accent1"/>
+          </a:fillRef>
+          <a:effectRef idx="2">
+            <a:schemeClr val="accent1"/>
+          </a:effectRef>
+          <a:fontRef idx="minor">
+            <a:schemeClr val="lt1"/>
+          </a:fontRef>
+        </p:style>
+        <p:txBody>
+          <a:bodyPr rtlCol="0" anchor="ctr" wrap="square"/>
+          <a:lstStyle/>
+          <a:p>
+            <a:pPr algn="ctr">
+              <a:defRPr b="1" sz="1150">
+                <a:solidFill>
+                  <a:srgbClr val="0D9488"/>
+                </a:solidFill>
+              </a:defRPr>
+            </a:pPr>
+            <a:r>
+              <a:t>Step 3: Clinical Prompt Tuning</a:t>
+            </a:r>
+          </a:p>
+          <a:p>
+            <a:pPr>
+              <a:defRPr sz="950">
+                <a:solidFill>
+                  <a:srgbClr val="334155"/>
+                </a:solidFill>
+              </a:defRPr>
+            </a:pPr>
+            <a:r>
+              <a:t>• Injects varied radiologist query templates.</a:t>
+            </a:r>
+          </a:p>
+          <a:p>
+            <a:pPr>
+              <a:defRPr sz="950">
+                <a:solidFill>
+                  <a:srgbClr val="334155"/>
+                </a:solidFill>
+              </a:defRPr>
+            </a:pPr>
+            <a:r>
+              <a:t>• Structures dialogue with &lt;image&gt; tags.</a:t>
+            </a:r>
+          </a:p>
+          <a:p>
+            <a:pPr>
+              <a:defRPr sz="950">
+                <a:solidFill>
+                  <a:srgbClr val="334155"/>
+                </a:solidFill>
+              </a:defRPr>
+            </a:pPr>
+            <a:r>
+              <a:t>• Formulates detailed diagnostic findings and clinical impressions.</a:t>
+            </a:r>
+          </a:p>
+        </p:txBody>
+      </p:sp>
+      <p:sp>
+        <p:nvSpPr>
+          <p:cNvPr id="9" name="Rounded Rectangle 8"/>
+          <p:cNvSpPr/>
+          <p:nvPr/>
+        </p:nvSpPr>
+        <p:spPr>
+          <a:xfrm>
+            <a:off x="731520" y="3794760"/>
+            <a:ext cx="5257800" cy="2468880"/>
+          </a:xfrm>
+          <a:prstGeom prst="roundRect">
+            <a:avLst/>
+          </a:prstGeom>
+          <a:solidFill>
+            <a:srgbClr val="FFFFFF"/>
+          </a:solidFill>
+          <a:ln>
+            <a:solidFill>
+              <a:srgbClr val="E2E8F0"/>
+            </a:solidFill>
+          </a:ln>
+        </p:spPr>
+        <p:style>
+          <a:lnRef idx="1">
+            <a:schemeClr val="accent1"/>
+          </a:lnRef>
+          <a:fillRef idx="3">
+            <a:schemeClr val="accent1"/>
+          </a:fillRef>
+          <a:effectRef idx="2">
+            <a:schemeClr val="accent1"/>
+          </a:effectRef>
+          <a:fontRef idx="minor">
+            <a:schemeClr val="lt1"/>
+          </a:fontRef>
+        </p:style>
+        <p:txBody>
+          <a:bodyPr rtlCol="0" anchor="ctr" wrap="square"/>
+          <a:lstStyle/>
+          <a:p>
+            <a:pPr algn="ctr">
+              <a:defRPr b="1" sz="1150">
+                <a:solidFill>
+                  <a:srgbClr val="0F172A"/>
+                </a:solidFill>
+              </a:defRPr>
+            </a:pPr>
+            <a:r>
+              <a:t>📊 Formatted Dataset Splits (1,438 Total Conversations)</a:t>
+            </a:r>
+          </a:p>
+          <a:p>
+            <a:pPr>
+              <a:defRPr sz="1000">
+                <a:solidFill>
+                  <a:srgbClr val="334155"/>
+                </a:solidFill>
+              </a:defRPr>
+            </a:pPr>
+            <a:r>
+              <a:t>• Training Set (train.json): 1,148 samples (574 fractured + 574 normal)</a:t>
+            </a:r>
+          </a:p>
+          <a:p>
+            <a:pPr>
+              <a:defRPr sz="1000">
+                <a:solidFill>
+                  <a:srgbClr val="334155"/>
+                </a:solidFill>
+              </a:defRPr>
+            </a:pPr>
+            <a:r>
+              <a:t>• Validation Set (val.json): 164 samples (82 fractured + 82 normal)</a:t>
+            </a:r>
+          </a:p>
+          <a:p>
+            <a:pPr>
+              <a:defRPr sz="1000">
+                <a:solidFill>
+                  <a:srgbClr val="334155"/>
+                </a:solidFill>
+              </a:defRPr>
+            </a:pPr>
+            <a:r>
+              <a:t>• Test Benchmark Set (test.json): 126 samples (63 fractured + 63 normal)</a:t>
+            </a:r>
+          </a:p>
+          <a:p>
+            <a:pPr>
+              <a:defRPr sz="1000">
+                <a:solidFill>
+                  <a:srgbClr val="334155"/>
+                </a:solidFill>
+              </a:defRPr>
+            </a:pPr>
+            <a:r>
+              <a:t>• Negative Ratio: 1.0 (Strictly enforced 1:1 balance for unbiased training)</a:t>
+            </a:r>
+          </a:p>
+          <a:p>
+            <a:pPr>
+              <a:defRPr sz="1000">
+                <a:solidFill>
+                  <a:srgbClr val="334155"/>
+                </a:solidFill>
+              </a:defRPr>
+            </a:pPr>
+            <a:r>
+              <a:t>• Summary File: data/processed/dataset_summary.json</a:t>
+            </a:r>
+          </a:p>
+        </p:txBody>
+      </p:sp>
+      <p:sp>
+        <p:nvSpPr>
+          <p:cNvPr id="10" name="Rounded Rectangle 9"/>
+          <p:cNvSpPr/>
+          <p:nvPr/>
+        </p:nvSpPr>
+        <p:spPr>
+          <a:xfrm>
+            <a:off x="6172200" y="3794760"/>
+            <a:ext cx="5257800" cy="2468880"/>
+          </a:xfrm>
+          <a:prstGeom prst="roundRect">
+            <a:avLst/>
+          </a:prstGeom>
+          <a:solidFill>
+            <a:srgbClr val="0F172A"/>
+          </a:solidFill>
+          <a:ln w="15240">
+            <a:solidFill>
+              <a:srgbClr val="0D9488"/>
+            </a:solidFill>
+          </a:ln>
+        </p:spPr>
+        <p:style>
+          <a:lnRef idx="1">
+            <a:schemeClr val="accent1"/>
+          </a:lnRef>
+          <a:fillRef idx="3">
+            <a:schemeClr val="accent1"/>
+          </a:fillRef>
+          <a:effectRef idx="2">
+            <a:schemeClr val="accent1"/>
+          </a:effectRef>
+          <a:fontRef idx="minor">
+            <a:schemeClr val="lt1"/>
+          </a:fontRef>
+        </p:style>
+        <p:txBody>
+          <a:bodyPr rtlCol="0" anchor="ctr" wrap="square"/>
+          <a:lstStyle/>
+          <a:p>
+            <a:pPr algn="ctr">
+              <a:defRPr b="1" sz="1100">
+                <a:solidFill>
+                  <a:srgbClr val="0D9488"/>
+                </a:solidFill>
+              </a:defRPr>
+            </a:pPr>
+            <a:r>
+              <a:t>📄 Standard LLaVA / ShareGPT Multimodal Schema</a:t>
+            </a:r>
+          </a:p>
+          <a:p>
+            <a:pPr>
+              <a:defRPr sz="850">
+                <a:solidFill>
+                  <a:srgbClr val="00FFC8"/>
+                </a:solidFill>
+                <a:latin typeface="Courier New"/>
+              </a:defRPr>
+            </a:pPr>
+            <a:r>
+              <a:t>{</a:t>
+            </a:r>
+            <a:br/>
+            <a:r>
+              <a:t>  "id": "frac_IMG0000019",</a:t>
+            </a:r>
+            <a:br/>
+            <a:r>
+              <a:t>  "image": "images/Fractured/IMG0000019.jpg",</a:t>
+            </a:r>
+            <a:br/>
+            <a:r>
+              <a:t>  "is_fractured": true,</a:t>
+            </a:r>
+            <a:br/>
+            <a:r>
+              <a:t>  "conversations": [</a:t>
+            </a:r>
+            <a:br/>
+            <a:r>
+              <a:t>    {"from": "human", "value": "&lt;image&gt;\nExamine radiograph."},</a:t>
+            </a:r>
+            <a:br/>
+            <a:r>
+              <a:t>    {"from": "gpt", "value": "FINDINGS: Acute fracture at [1242, 929, 1515, 1076]. Impression: Distal radius fracture."}</a:t>
+            </a:r>
+            <a:br/>
+            <a:r>
+              <a:t>  ]</a:t>
+            </a:r>
+            <a:br/>
+            <a:r>
+              <a:t>}</a:t>
+            </a:r>
+          </a:p>
+        </p:txBody>
+      </p:sp>
     </p:spTree>
   </p:cSld>
   <p:clrMapOvr>

</xml_diff>